<commit_message>
Redraw Fig 1 schematic panel (a)
</commit_message>
<xml_diff>
--- a/manuscript/figures/process-schematic-revised.pptx
+++ b/manuscript/figures/process-schematic-revised.pptx
@@ -5555,14 +5555,15 @@
           </p:cNvPr>
           <p:cNvCxnSpPr>
             <a:cxnSpLocks/>
+            <a:stCxn id="17" idx="4"/>
             <a:endCxn id="27" idx="4"/>
           </p:cNvCxnSpPr>
           <p:nvPr/>
         </p:nvCxnSpPr>
         <p:spPr>
           <a:xfrm>
-            <a:off x="8782753" y="1773603"/>
-            <a:ext cx="14005" cy="282643"/>
+            <a:off x="8796758" y="1774608"/>
+            <a:ext cx="0" cy="281638"/>
           </a:xfrm>
           <a:prstGeom prst="straightConnector1">
             <a:avLst/>
@@ -6084,10 +6085,10 @@
       </p:sp>
       <p:sp>
         <p:nvSpPr>
-          <p:cNvPr id="72" name="Freeform 71">
-            <a:extLst>
-              <a:ext uri="{FF2B5EF4-FFF2-40B4-BE49-F238E27FC236}">
-                <a16:creationId xmlns:a16="http://schemas.microsoft.com/office/drawing/2014/main" id="{D4C38097-2D01-A68E-0E3E-F18E8839C665}"/>
+          <p:cNvPr id="74" name="Freeform 73">
+            <a:extLst>
+              <a:ext uri="{FF2B5EF4-FFF2-40B4-BE49-F238E27FC236}">
+                <a16:creationId xmlns:a16="http://schemas.microsoft.com/office/drawing/2014/main" id="{4983B32B-E98C-A71F-EE99-0B584FDF714E}"/>
               </a:ext>
             </a:extLst>
           </p:cNvPr>
@@ -6096,8 +6097,1302 @@
         </p:nvSpPr>
         <p:spPr>
           <a:xfrm rot="583769">
-            <a:off x="6979708" y="4273191"/>
-            <a:ext cx="3500371" cy="1366311"/>
+            <a:off x="7077758" y="967516"/>
+            <a:ext cx="3455583" cy="230455"/>
+          </a:xfrm>
+          <a:custGeom>
+            <a:avLst/>
+            <a:gdLst>
+              <a:gd name="csX0" fmla="*/ 0 w 3455582"/>
+              <a:gd name="csY0" fmla="*/ 212977 h 319302"/>
+              <a:gd name="csX1" fmla="*/ 499730 w 3455582"/>
+              <a:gd name="csY1" fmla="*/ 325 h 319302"/>
+              <a:gd name="csX2" fmla="*/ 978196 w 3455582"/>
+              <a:gd name="csY2" fmla="*/ 255507 h 319302"/>
+              <a:gd name="csX3" fmla="*/ 1371600 w 3455582"/>
+              <a:gd name="csY3" fmla="*/ 10958 h 319302"/>
+              <a:gd name="csX4" fmla="*/ 1743740 w 3455582"/>
+              <a:gd name="csY4" fmla="*/ 255507 h 319302"/>
+              <a:gd name="csX5" fmla="*/ 2126512 w 3455582"/>
+              <a:gd name="csY5" fmla="*/ 32223 h 319302"/>
+              <a:gd name="csX6" fmla="*/ 2562447 w 3455582"/>
+              <a:gd name="csY6" fmla="*/ 298037 h 319302"/>
+              <a:gd name="csX7" fmla="*/ 3051544 w 3455582"/>
+              <a:gd name="csY7" fmla="*/ 64121 h 319302"/>
+              <a:gd name="csX8" fmla="*/ 3455582 w 3455582"/>
+              <a:gd name="csY8" fmla="*/ 319302 h 319302"/>
+            </a:gdLst>
+            <a:ahLst/>
+            <a:cxnLst>
+              <a:cxn ang="0">
+                <a:pos x="csX0" y="csY0"/>
+              </a:cxn>
+              <a:cxn ang="0">
+                <a:pos x="csX1" y="csY1"/>
+              </a:cxn>
+              <a:cxn ang="0">
+                <a:pos x="csX2" y="csY2"/>
+              </a:cxn>
+              <a:cxn ang="0">
+                <a:pos x="csX3" y="csY3"/>
+              </a:cxn>
+              <a:cxn ang="0">
+                <a:pos x="csX4" y="csY4"/>
+              </a:cxn>
+              <a:cxn ang="0">
+                <a:pos x="csX5" y="csY5"/>
+              </a:cxn>
+              <a:cxn ang="0">
+                <a:pos x="csX6" y="csY6"/>
+              </a:cxn>
+              <a:cxn ang="0">
+                <a:pos x="csX7" y="csY7"/>
+              </a:cxn>
+              <a:cxn ang="0">
+                <a:pos x="csX8" y="csY8"/>
+              </a:cxn>
+            </a:cxnLst>
+            <a:rect l="l" t="t" r="r" b="b"/>
+            <a:pathLst>
+              <a:path w="3455582" h="319302">
+                <a:moveTo>
+                  <a:pt x="0" y="212977"/>
+                </a:moveTo>
+                <a:cubicBezTo>
+                  <a:pt x="168348" y="103107"/>
+                  <a:pt x="336697" y="-6763"/>
+                  <a:pt x="499730" y="325"/>
+                </a:cubicBezTo>
+                <a:cubicBezTo>
+                  <a:pt x="662763" y="7413"/>
+                  <a:pt x="832884" y="253735"/>
+                  <a:pt x="978196" y="255507"/>
+                </a:cubicBezTo>
+                <a:cubicBezTo>
+                  <a:pt x="1123508" y="257279"/>
+                  <a:pt x="1244009" y="10958"/>
+                  <a:pt x="1371600" y="10958"/>
+                </a:cubicBezTo>
+                <a:cubicBezTo>
+                  <a:pt x="1499191" y="10958"/>
+                  <a:pt x="1617921" y="251963"/>
+                  <a:pt x="1743740" y="255507"/>
+                </a:cubicBezTo>
+                <a:cubicBezTo>
+                  <a:pt x="1869559" y="259051"/>
+                  <a:pt x="1990061" y="25135"/>
+                  <a:pt x="2126512" y="32223"/>
+                </a:cubicBezTo>
+                <a:cubicBezTo>
+                  <a:pt x="2262963" y="39311"/>
+                  <a:pt x="2408275" y="292721"/>
+                  <a:pt x="2562447" y="298037"/>
+                </a:cubicBezTo>
+                <a:cubicBezTo>
+                  <a:pt x="2716619" y="303353"/>
+                  <a:pt x="2902688" y="60577"/>
+                  <a:pt x="3051544" y="64121"/>
+                </a:cubicBezTo>
+                <a:cubicBezTo>
+                  <a:pt x="3200400" y="67665"/>
+                  <a:pt x="3327991" y="193483"/>
+                  <a:pt x="3455582" y="319302"/>
+                </a:cubicBezTo>
+              </a:path>
+            </a:pathLst>
+          </a:custGeom>
+          <a:noFill/>
+          <a:ln w="28575">
+            <a:solidFill>
+              <a:schemeClr val="accent6">
+                <a:lumMod val="75000"/>
+              </a:schemeClr>
+            </a:solidFill>
+            <a:prstDash val="sysDot"/>
+          </a:ln>
+        </p:spPr>
+        <p:style>
+          <a:lnRef idx="2">
+            <a:schemeClr val="accent1">
+              <a:shade val="15000"/>
+            </a:schemeClr>
+          </a:lnRef>
+          <a:fillRef idx="1">
+            <a:schemeClr val="accent1"/>
+          </a:fillRef>
+          <a:effectRef idx="0">
+            <a:schemeClr val="accent1"/>
+          </a:effectRef>
+          <a:fontRef idx="minor">
+            <a:schemeClr val="lt1"/>
+          </a:fontRef>
+        </p:style>
+        <p:txBody>
+          <a:bodyPr rtlCol="0" anchor="ctr"/>
+          <a:lstStyle/>
+          <a:p>
+            <a:pPr algn="ctr"/>
+            <a:endParaRPr lang="en-US"/>
+          </a:p>
+        </p:txBody>
+      </p:sp>
+      <p:sp>
+        <p:nvSpPr>
+          <p:cNvPr id="79" name="Freeform 78">
+            <a:extLst>
+              <a:ext uri="{FF2B5EF4-FFF2-40B4-BE49-F238E27FC236}">
+                <a16:creationId xmlns:a16="http://schemas.microsoft.com/office/drawing/2014/main" id="{9BFE1455-5F70-9CA9-B90D-4975B02B9C9E}"/>
+              </a:ext>
+            </a:extLst>
+          </p:cNvPr>
+          <p:cNvSpPr/>
+          <p:nvPr/>
+        </p:nvSpPr>
+        <p:spPr>
+          <a:xfrm rot="583769">
+            <a:off x="8389230" y="5451876"/>
+            <a:ext cx="1186573" cy="642912"/>
+          </a:xfrm>
+          <a:custGeom>
+            <a:avLst/>
+            <a:gdLst>
+              <a:gd name="csX0" fmla="*/ 0 w 3455582"/>
+              <a:gd name="csY0" fmla="*/ 212977 h 319302"/>
+              <a:gd name="csX1" fmla="*/ 499730 w 3455582"/>
+              <a:gd name="csY1" fmla="*/ 325 h 319302"/>
+              <a:gd name="csX2" fmla="*/ 978196 w 3455582"/>
+              <a:gd name="csY2" fmla="*/ 255507 h 319302"/>
+              <a:gd name="csX3" fmla="*/ 1371600 w 3455582"/>
+              <a:gd name="csY3" fmla="*/ 10958 h 319302"/>
+              <a:gd name="csX4" fmla="*/ 1743740 w 3455582"/>
+              <a:gd name="csY4" fmla="*/ 255507 h 319302"/>
+              <a:gd name="csX5" fmla="*/ 2126512 w 3455582"/>
+              <a:gd name="csY5" fmla="*/ 32223 h 319302"/>
+              <a:gd name="csX6" fmla="*/ 2562447 w 3455582"/>
+              <a:gd name="csY6" fmla="*/ 298037 h 319302"/>
+              <a:gd name="csX7" fmla="*/ 3051544 w 3455582"/>
+              <a:gd name="csY7" fmla="*/ 64121 h 319302"/>
+              <a:gd name="csX8" fmla="*/ 3455582 w 3455582"/>
+              <a:gd name="csY8" fmla="*/ 319302 h 319302"/>
+              <a:gd name="csX0" fmla="*/ 0 w 3455582"/>
+              <a:gd name="csY0" fmla="*/ 218043 h 324368"/>
+              <a:gd name="csX1" fmla="*/ 499730 w 3455582"/>
+              <a:gd name="csY1" fmla="*/ 5391 h 324368"/>
+              <a:gd name="csX2" fmla="*/ 834136 w 3455582"/>
+              <a:gd name="csY2" fmla="*/ 59721 h 324368"/>
+              <a:gd name="csX3" fmla="*/ 1371600 w 3455582"/>
+              <a:gd name="csY3" fmla="*/ 16024 h 324368"/>
+              <a:gd name="csX4" fmla="*/ 1743740 w 3455582"/>
+              <a:gd name="csY4" fmla="*/ 260573 h 324368"/>
+              <a:gd name="csX5" fmla="*/ 2126512 w 3455582"/>
+              <a:gd name="csY5" fmla="*/ 37289 h 324368"/>
+              <a:gd name="csX6" fmla="*/ 2562447 w 3455582"/>
+              <a:gd name="csY6" fmla="*/ 303103 h 324368"/>
+              <a:gd name="csX7" fmla="*/ 3051544 w 3455582"/>
+              <a:gd name="csY7" fmla="*/ 69187 h 324368"/>
+              <a:gd name="csX8" fmla="*/ 3455582 w 3455582"/>
+              <a:gd name="csY8" fmla="*/ 324368 h 324368"/>
+              <a:gd name="csX0" fmla="*/ 0 w 2955852"/>
+              <a:gd name="csY0" fmla="*/ 5391 h 324368"/>
+              <a:gd name="csX1" fmla="*/ 334406 w 2955852"/>
+              <a:gd name="csY1" fmla="*/ 59721 h 324368"/>
+              <a:gd name="csX2" fmla="*/ 871870 w 2955852"/>
+              <a:gd name="csY2" fmla="*/ 16024 h 324368"/>
+              <a:gd name="csX3" fmla="*/ 1244010 w 2955852"/>
+              <a:gd name="csY3" fmla="*/ 260573 h 324368"/>
+              <a:gd name="csX4" fmla="*/ 1626782 w 2955852"/>
+              <a:gd name="csY4" fmla="*/ 37289 h 324368"/>
+              <a:gd name="csX5" fmla="*/ 2062717 w 2955852"/>
+              <a:gd name="csY5" fmla="*/ 303103 h 324368"/>
+              <a:gd name="csX6" fmla="*/ 2551814 w 2955852"/>
+              <a:gd name="csY6" fmla="*/ 69187 h 324368"/>
+              <a:gd name="csX7" fmla="*/ 2955852 w 2955852"/>
+              <a:gd name="csY7" fmla="*/ 324368 h 324368"/>
+              <a:gd name="csX0" fmla="*/ 0 w 2621446"/>
+              <a:gd name="csY0" fmla="*/ 51978 h 316625"/>
+              <a:gd name="csX1" fmla="*/ 537464 w 2621446"/>
+              <a:gd name="csY1" fmla="*/ 8281 h 316625"/>
+              <a:gd name="csX2" fmla="*/ 909604 w 2621446"/>
+              <a:gd name="csY2" fmla="*/ 252830 h 316625"/>
+              <a:gd name="csX3" fmla="*/ 1292376 w 2621446"/>
+              <a:gd name="csY3" fmla="*/ 29546 h 316625"/>
+              <a:gd name="csX4" fmla="*/ 1728311 w 2621446"/>
+              <a:gd name="csY4" fmla="*/ 295360 h 316625"/>
+              <a:gd name="csX5" fmla="*/ 2217408 w 2621446"/>
+              <a:gd name="csY5" fmla="*/ 61444 h 316625"/>
+              <a:gd name="csX6" fmla="*/ 2621446 w 2621446"/>
+              <a:gd name="csY6" fmla="*/ 316625 h 316625"/>
+              <a:gd name="csX0" fmla="*/ 0 w 2396848"/>
+              <a:gd name="csY0" fmla="*/ 28441 h 321940"/>
+              <a:gd name="csX1" fmla="*/ 312866 w 2396848"/>
+              <a:gd name="csY1" fmla="*/ 13596 h 321940"/>
+              <a:gd name="csX2" fmla="*/ 685006 w 2396848"/>
+              <a:gd name="csY2" fmla="*/ 258145 h 321940"/>
+              <a:gd name="csX3" fmla="*/ 1067778 w 2396848"/>
+              <a:gd name="csY3" fmla="*/ 34861 h 321940"/>
+              <a:gd name="csX4" fmla="*/ 1503713 w 2396848"/>
+              <a:gd name="csY4" fmla="*/ 300675 h 321940"/>
+              <a:gd name="csX5" fmla="*/ 1992810 w 2396848"/>
+              <a:gd name="csY5" fmla="*/ 66759 h 321940"/>
+              <a:gd name="csX6" fmla="*/ 2396848 w 2396848"/>
+              <a:gd name="csY6" fmla="*/ 321940 h 321940"/>
+              <a:gd name="csX0" fmla="*/ 0 w 2376820"/>
+              <a:gd name="csY0" fmla="*/ 22671 h 323946"/>
+              <a:gd name="csX1" fmla="*/ 292838 w 2376820"/>
+              <a:gd name="csY1" fmla="*/ 15602 h 323946"/>
+              <a:gd name="csX2" fmla="*/ 664978 w 2376820"/>
+              <a:gd name="csY2" fmla="*/ 260151 h 323946"/>
+              <a:gd name="csX3" fmla="*/ 1047750 w 2376820"/>
+              <a:gd name="csY3" fmla="*/ 36867 h 323946"/>
+              <a:gd name="csX4" fmla="*/ 1483685 w 2376820"/>
+              <a:gd name="csY4" fmla="*/ 302681 h 323946"/>
+              <a:gd name="csX5" fmla="*/ 1972782 w 2376820"/>
+              <a:gd name="csY5" fmla="*/ 68765 h 323946"/>
+              <a:gd name="csX6" fmla="*/ 2376820 w 2376820"/>
+              <a:gd name="csY6" fmla="*/ 323946 h 323946"/>
+              <a:gd name="csX0" fmla="*/ 0 w 1972782"/>
+              <a:gd name="csY0" fmla="*/ 22671 h 302767"/>
+              <a:gd name="csX1" fmla="*/ 292838 w 1972782"/>
+              <a:gd name="csY1" fmla="*/ 15602 h 302767"/>
+              <a:gd name="csX2" fmla="*/ 664978 w 1972782"/>
+              <a:gd name="csY2" fmla="*/ 260151 h 302767"/>
+              <a:gd name="csX3" fmla="*/ 1047750 w 1972782"/>
+              <a:gd name="csY3" fmla="*/ 36867 h 302767"/>
+              <a:gd name="csX4" fmla="*/ 1483685 w 1972782"/>
+              <a:gd name="csY4" fmla="*/ 302681 h 302767"/>
+              <a:gd name="csX5" fmla="*/ 1972782 w 1972782"/>
+              <a:gd name="csY5" fmla="*/ 68765 h 302767"/>
+              <a:gd name="csX0" fmla="*/ 0 w 1483685"/>
+              <a:gd name="csY0" fmla="*/ 22671 h 302681"/>
+              <a:gd name="csX1" fmla="*/ 292838 w 1483685"/>
+              <a:gd name="csY1" fmla="*/ 15602 h 302681"/>
+              <a:gd name="csX2" fmla="*/ 664978 w 1483685"/>
+              <a:gd name="csY2" fmla="*/ 260151 h 302681"/>
+              <a:gd name="csX3" fmla="*/ 1047750 w 1483685"/>
+              <a:gd name="csY3" fmla="*/ 36867 h 302681"/>
+              <a:gd name="csX4" fmla="*/ 1483685 w 1483685"/>
+              <a:gd name="csY4" fmla="*/ 302681 h 302681"/>
+              <a:gd name="csX0" fmla="*/ 0 w 1479410"/>
+              <a:gd name="csY0" fmla="*/ 39882 h 1488779"/>
+              <a:gd name="csX1" fmla="*/ 292838 w 1479410"/>
+              <a:gd name="csY1" fmla="*/ 32813 h 1488779"/>
+              <a:gd name="csX2" fmla="*/ 664978 w 1479410"/>
+              <a:gd name="csY2" fmla="*/ 277362 h 1488779"/>
+              <a:gd name="csX3" fmla="*/ 1047750 w 1479410"/>
+              <a:gd name="csY3" fmla="*/ 54078 h 1488779"/>
+              <a:gd name="csX4" fmla="*/ 1479410 w 1479410"/>
+              <a:gd name="csY4" fmla="*/ 1488778 h 1488779"/>
+              <a:gd name="csX0" fmla="*/ 0 w 1479410"/>
+              <a:gd name="csY0" fmla="*/ 22673 h 1471570"/>
+              <a:gd name="csX1" fmla="*/ 292838 w 1479410"/>
+              <a:gd name="csY1" fmla="*/ 15604 h 1471570"/>
+              <a:gd name="csX2" fmla="*/ 664978 w 1479410"/>
+              <a:gd name="csY2" fmla="*/ 260153 h 1471570"/>
+              <a:gd name="csX3" fmla="*/ 1109694 w 1479410"/>
+              <a:gd name="csY3" fmla="*/ 106194 h 1471570"/>
+              <a:gd name="csX4" fmla="*/ 1479410 w 1479410"/>
+              <a:gd name="csY4" fmla="*/ 1471569 h 1471570"/>
+              <a:gd name="csX0" fmla="*/ 0 w 1186572"/>
+              <a:gd name="csY0" fmla="*/ 1 h 1455967"/>
+              <a:gd name="csX1" fmla="*/ 372140 w 1186572"/>
+              <a:gd name="csY1" fmla="*/ 244550 h 1455967"/>
+              <a:gd name="csX2" fmla="*/ 816856 w 1186572"/>
+              <a:gd name="csY2" fmla="*/ 90591 h 1455967"/>
+              <a:gd name="csX3" fmla="*/ 1186572 w 1186572"/>
+              <a:gd name="csY3" fmla="*/ 1455966 h 1455967"/>
+            </a:gdLst>
+            <a:ahLst/>
+            <a:cxnLst>
+              <a:cxn ang="0">
+                <a:pos x="csX0" y="csY0"/>
+              </a:cxn>
+              <a:cxn ang="0">
+                <a:pos x="csX1" y="csY1"/>
+              </a:cxn>
+              <a:cxn ang="0">
+                <a:pos x="csX2" y="csY2"/>
+              </a:cxn>
+              <a:cxn ang="0">
+                <a:pos x="csX3" y="csY3"/>
+              </a:cxn>
+            </a:cxnLst>
+            <a:rect l="l" t="t" r="r" b="b"/>
+            <a:pathLst>
+              <a:path w="1186572" h="1455967">
+                <a:moveTo>
+                  <a:pt x="0" y="1"/>
+                </a:moveTo>
+                <a:cubicBezTo>
+                  <a:pt x="110830" y="39581"/>
+                  <a:pt x="235997" y="229452"/>
+                  <a:pt x="372140" y="244550"/>
+                </a:cubicBezTo>
+                <a:cubicBezTo>
+                  <a:pt x="508283" y="259648"/>
+                  <a:pt x="681117" y="-111312"/>
+                  <a:pt x="816856" y="90591"/>
+                </a:cubicBezTo>
+                <a:cubicBezTo>
+                  <a:pt x="952595" y="292494"/>
+                  <a:pt x="1032400" y="1450650"/>
+                  <a:pt x="1186572" y="1455966"/>
+                </a:cubicBezTo>
+              </a:path>
+            </a:pathLst>
+          </a:custGeom>
+          <a:noFill/>
+          <a:ln w="28575">
+            <a:solidFill>
+              <a:srgbClr val="C00000"/>
+            </a:solidFill>
+            <a:prstDash val="solid"/>
+          </a:ln>
+        </p:spPr>
+        <p:style>
+          <a:lnRef idx="2">
+            <a:schemeClr val="accent1">
+              <a:shade val="15000"/>
+            </a:schemeClr>
+          </a:lnRef>
+          <a:fillRef idx="1">
+            <a:schemeClr val="accent1"/>
+          </a:fillRef>
+          <a:effectRef idx="0">
+            <a:schemeClr val="accent1"/>
+          </a:effectRef>
+          <a:fontRef idx="minor">
+            <a:schemeClr val="lt1"/>
+          </a:fontRef>
+        </p:style>
+        <p:txBody>
+          <a:bodyPr rtlCol="0" anchor="ctr"/>
+          <a:lstStyle/>
+          <a:p>
+            <a:pPr algn="ctr"/>
+            <a:endParaRPr lang="en-US"/>
+          </a:p>
+        </p:txBody>
+      </p:sp>
+      <p:sp>
+        <p:nvSpPr>
+          <p:cNvPr id="80" name="Freeform 79">
+            <a:extLst>
+              <a:ext uri="{FF2B5EF4-FFF2-40B4-BE49-F238E27FC236}">
+                <a16:creationId xmlns:a16="http://schemas.microsoft.com/office/drawing/2014/main" id="{5E2B6793-6B9C-BDD2-E9E0-21CBDFA7F9EA}"/>
+              </a:ext>
+            </a:extLst>
+          </p:cNvPr>
+          <p:cNvSpPr/>
+          <p:nvPr/>
+        </p:nvSpPr>
+        <p:spPr>
+          <a:xfrm rot="583769">
+            <a:off x="10336818" y="5890313"/>
+            <a:ext cx="130645" cy="309477"/>
+          </a:xfrm>
+          <a:custGeom>
+            <a:avLst/>
+            <a:gdLst>
+              <a:gd name="csX0" fmla="*/ 0 w 3455582"/>
+              <a:gd name="csY0" fmla="*/ 212977 h 319302"/>
+              <a:gd name="csX1" fmla="*/ 499730 w 3455582"/>
+              <a:gd name="csY1" fmla="*/ 325 h 319302"/>
+              <a:gd name="csX2" fmla="*/ 978196 w 3455582"/>
+              <a:gd name="csY2" fmla="*/ 255507 h 319302"/>
+              <a:gd name="csX3" fmla="*/ 1371600 w 3455582"/>
+              <a:gd name="csY3" fmla="*/ 10958 h 319302"/>
+              <a:gd name="csX4" fmla="*/ 1743740 w 3455582"/>
+              <a:gd name="csY4" fmla="*/ 255507 h 319302"/>
+              <a:gd name="csX5" fmla="*/ 2126512 w 3455582"/>
+              <a:gd name="csY5" fmla="*/ 32223 h 319302"/>
+              <a:gd name="csX6" fmla="*/ 2562447 w 3455582"/>
+              <a:gd name="csY6" fmla="*/ 298037 h 319302"/>
+              <a:gd name="csX7" fmla="*/ 3051544 w 3455582"/>
+              <a:gd name="csY7" fmla="*/ 64121 h 319302"/>
+              <a:gd name="csX8" fmla="*/ 3455582 w 3455582"/>
+              <a:gd name="csY8" fmla="*/ 319302 h 319302"/>
+              <a:gd name="csX0" fmla="*/ 0 w 3455582"/>
+              <a:gd name="csY0" fmla="*/ 218043 h 324368"/>
+              <a:gd name="csX1" fmla="*/ 499730 w 3455582"/>
+              <a:gd name="csY1" fmla="*/ 5391 h 324368"/>
+              <a:gd name="csX2" fmla="*/ 834136 w 3455582"/>
+              <a:gd name="csY2" fmla="*/ 59721 h 324368"/>
+              <a:gd name="csX3" fmla="*/ 1371600 w 3455582"/>
+              <a:gd name="csY3" fmla="*/ 16024 h 324368"/>
+              <a:gd name="csX4" fmla="*/ 1743740 w 3455582"/>
+              <a:gd name="csY4" fmla="*/ 260573 h 324368"/>
+              <a:gd name="csX5" fmla="*/ 2126512 w 3455582"/>
+              <a:gd name="csY5" fmla="*/ 37289 h 324368"/>
+              <a:gd name="csX6" fmla="*/ 2562447 w 3455582"/>
+              <a:gd name="csY6" fmla="*/ 303103 h 324368"/>
+              <a:gd name="csX7" fmla="*/ 3051544 w 3455582"/>
+              <a:gd name="csY7" fmla="*/ 69187 h 324368"/>
+              <a:gd name="csX8" fmla="*/ 3455582 w 3455582"/>
+              <a:gd name="csY8" fmla="*/ 324368 h 324368"/>
+              <a:gd name="csX0" fmla="*/ 0 w 2955852"/>
+              <a:gd name="csY0" fmla="*/ 5391 h 324368"/>
+              <a:gd name="csX1" fmla="*/ 334406 w 2955852"/>
+              <a:gd name="csY1" fmla="*/ 59721 h 324368"/>
+              <a:gd name="csX2" fmla="*/ 871870 w 2955852"/>
+              <a:gd name="csY2" fmla="*/ 16024 h 324368"/>
+              <a:gd name="csX3" fmla="*/ 1244010 w 2955852"/>
+              <a:gd name="csY3" fmla="*/ 260573 h 324368"/>
+              <a:gd name="csX4" fmla="*/ 1626782 w 2955852"/>
+              <a:gd name="csY4" fmla="*/ 37289 h 324368"/>
+              <a:gd name="csX5" fmla="*/ 2062717 w 2955852"/>
+              <a:gd name="csY5" fmla="*/ 303103 h 324368"/>
+              <a:gd name="csX6" fmla="*/ 2551814 w 2955852"/>
+              <a:gd name="csY6" fmla="*/ 69187 h 324368"/>
+              <a:gd name="csX7" fmla="*/ 2955852 w 2955852"/>
+              <a:gd name="csY7" fmla="*/ 324368 h 324368"/>
+              <a:gd name="csX0" fmla="*/ 0 w 2621446"/>
+              <a:gd name="csY0" fmla="*/ 51978 h 316625"/>
+              <a:gd name="csX1" fmla="*/ 537464 w 2621446"/>
+              <a:gd name="csY1" fmla="*/ 8281 h 316625"/>
+              <a:gd name="csX2" fmla="*/ 909604 w 2621446"/>
+              <a:gd name="csY2" fmla="*/ 252830 h 316625"/>
+              <a:gd name="csX3" fmla="*/ 1292376 w 2621446"/>
+              <a:gd name="csY3" fmla="*/ 29546 h 316625"/>
+              <a:gd name="csX4" fmla="*/ 1728311 w 2621446"/>
+              <a:gd name="csY4" fmla="*/ 295360 h 316625"/>
+              <a:gd name="csX5" fmla="*/ 2217408 w 2621446"/>
+              <a:gd name="csY5" fmla="*/ 61444 h 316625"/>
+              <a:gd name="csX6" fmla="*/ 2621446 w 2621446"/>
+              <a:gd name="csY6" fmla="*/ 316625 h 316625"/>
+              <a:gd name="csX0" fmla="*/ 0 w 2396848"/>
+              <a:gd name="csY0" fmla="*/ 28441 h 321940"/>
+              <a:gd name="csX1" fmla="*/ 312866 w 2396848"/>
+              <a:gd name="csY1" fmla="*/ 13596 h 321940"/>
+              <a:gd name="csX2" fmla="*/ 685006 w 2396848"/>
+              <a:gd name="csY2" fmla="*/ 258145 h 321940"/>
+              <a:gd name="csX3" fmla="*/ 1067778 w 2396848"/>
+              <a:gd name="csY3" fmla="*/ 34861 h 321940"/>
+              <a:gd name="csX4" fmla="*/ 1503713 w 2396848"/>
+              <a:gd name="csY4" fmla="*/ 300675 h 321940"/>
+              <a:gd name="csX5" fmla="*/ 1992810 w 2396848"/>
+              <a:gd name="csY5" fmla="*/ 66759 h 321940"/>
+              <a:gd name="csX6" fmla="*/ 2396848 w 2396848"/>
+              <a:gd name="csY6" fmla="*/ 321940 h 321940"/>
+              <a:gd name="csX0" fmla="*/ 0 w 2376820"/>
+              <a:gd name="csY0" fmla="*/ 22671 h 323946"/>
+              <a:gd name="csX1" fmla="*/ 292838 w 2376820"/>
+              <a:gd name="csY1" fmla="*/ 15602 h 323946"/>
+              <a:gd name="csX2" fmla="*/ 664978 w 2376820"/>
+              <a:gd name="csY2" fmla="*/ 260151 h 323946"/>
+              <a:gd name="csX3" fmla="*/ 1047750 w 2376820"/>
+              <a:gd name="csY3" fmla="*/ 36867 h 323946"/>
+              <a:gd name="csX4" fmla="*/ 1483685 w 2376820"/>
+              <a:gd name="csY4" fmla="*/ 302681 h 323946"/>
+              <a:gd name="csX5" fmla="*/ 1972782 w 2376820"/>
+              <a:gd name="csY5" fmla="*/ 68765 h 323946"/>
+              <a:gd name="csX6" fmla="*/ 2376820 w 2376820"/>
+              <a:gd name="csY6" fmla="*/ 323946 h 323946"/>
+              <a:gd name="csX0" fmla="*/ 0 w 2083982"/>
+              <a:gd name="csY0" fmla="*/ 1 h 308345"/>
+              <a:gd name="csX1" fmla="*/ 372140 w 2083982"/>
+              <a:gd name="csY1" fmla="*/ 244550 h 308345"/>
+              <a:gd name="csX2" fmla="*/ 754912 w 2083982"/>
+              <a:gd name="csY2" fmla="*/ 21266 h 308345"/>
+              <a:gd name="csX3" fmla="*/ 1190847 w 2083982"/>
+              <a:gd name="csY3" fmla="*/ 287080 h 308345"/>
+              <a:gd name="csX4" fmla="*/ 1679944 w 2083982"/>
+              <a:gd name="csY4" fmla="*/ 53164 h 308345"/>
+              <a:gd name="csX5" fmla="*/ 2083982 w 2083982"/>
+              <a:gd name="csY5" fmla="*/ 308345 h 308345"/>
+              <a:gd name="csX0" fmla="*/ 0 w 1711842"/>
+              <a:gd name="csY0" fmla="*/ 223441 h 287236"/>
+              <a:gd name="csX1" fmla="*/ 382772 w 1711842"/>
+              <a:gd name="csY1" fmla="*/ 157 h 287236"/>
+              <a:gd name="csX2" fmla="*/ 818707 w 1711842"/>
+              <a:gd name="csY2" fmla="*/ 265971 h 287236"/>
+              <a:gd name="csX3" fmla="*/ 1307804 w 1711842"/>
+              <a:gd name="csY3" fmla="*/ 32055 h 287236"/>
+              <a:gd name="csX4" fmla="*/ 1711842 w 1711842"/>
+              <a:gd name="csY4" fmla="*/ 287236 h 287236"/>
+              <a:gd name="csX0" fmla="*/ 0 w 1329070"/>
+              <a:gd name="csY0" fmla="*/ 1 h 287080"/>
+              <a:gd name="csX1" fmla="*/ 435935 w 1329070"/>
+              <a:gd name="csY1" fmla="*/ 265815 h 287080"/>
+              <a:gd name="csX2" fmla="*/ 925032 w 1329070"/>
+              <a:gd name="csY2" fmla="*/ 31899 h 287080"/>
+              <a:gd name="csX3" fmla="*/ 1329070 w 1329070"/>
+              <a:gd name="csY3" fmla="*/ 287080 h 287080"/>
+              <a:gd name="csX0" fmla="*/ 0 w 893135"/>
+              <a:gd name="csY0" fmla="*/ 233956 h 255221"/>
+              <a:gd name="csX1" fmla="*/ 489097 w 893135"/>
+              <a:gd name="csY1" fmla="*/ 40 h 255221"/>
+              <a:gd name="csX2" fmla="*/ 893135 w 893135"/>
+              <a:gd name="csY2" fmla="*/ 255221 h 255221"/>
+              <a:gd name="csX0" fmla="*/ 0 w 404038"/>
+              <a:gd name="csY0" fmla="*/ -1 h 255180"/>
+              <a:gd name="csX1" fmla="*/ 404038 w 404038"/>
+              <a:gd name="csY1" fmla="*/ 255180 h 255180"/>
+              <a:gd name="csX0" fmla="*/ 0 w 124491"/>
+              <a:gd name="csY0" fmla="*/ 861348 h 861357"/>
+              <a:gd name="csX1" fmla="*/ 124491 w 124491"/>
+              <a:gd name="csY1" fmla="*/ 11160 h 861357"/>
+              <a:gd name="csX0" fmla="*/ 0 w 150102"/>
+              <a:gd name="csY0" fmla="*/ 594958 h 594972"/>
+              <a:gd name="csX1" fmla="*/ 150102 w 150102"/>
+              <a:gd name="csY1" fmla="*/ 14960 h 594972"/>
+              <a:gd name="csX0" fmla="*/ 0 w 130645"/>
+              <a:gd name="csY0" fmla="*/ 713820 h 713832"/>
+              <a:gd name="csX1" fmla="*/ 130645 w 130645"/>
+              <a:gd name="csY1" fmla="*/ 12981 h 713832"/>
+              <a:gd name="csX0" fmla="*/ 0 w 130645"/>
+              <a:gd name="csY0" fmla="*/ 700839 h 700856"/>
+              <a:gd name="csX1" fmla="*/ 130645 w 130645"/>
+              <a:gd name="csY1" fmla="*/ 0 h 700856"/>
+            </a:gdLst>
+            <a:ahLst/>
+            <a:cxnLst>
+              <a:cxn ang="0">
+                <a:pos x="csX0" y="csY0"/>
+              </a:cxn>
+              <a:cxn ang="0">
+                <a:pos x="csX1" y="csY1"/>
+              </a:cxn>
+            </a:cxnLst>
+            <a:rect l="l" t="t" r="r" b="b"/>
+            <a:pathLst>
+              <a:path w="130645" h="700856">
+                <a:moveTo>
+                  <a:pt x="0" y="700839"/>
+                </a:moveTo>
+                <a:cubicBezTo>
+                  <a:pt x="148856" y="704383"/>
+                  <a:pt x="51268" y="170612"/>
+                  <a:pt x="130645" y="0"/>
+                </a:cubicBezTo>
+              </a:path>
+            </a:pathLst>
+          </a:custGeom>
+          <a:noFill/>
+          <a:ln w="28575">
+            <a:solidFill>
+              <a:srgbClr val="C00000"/>
+            </a:solidFill>
+            <a:prstDash val="solid"/>
+          </a:ln>
+        </p:spPr>
+        <p:style>
+          <a:lnRef idx="2">
+            <a:schemeClr val="accent1">
+              <a:shade val="15000"/>
+            </a:schemeClr>
+          </a:lnRef>
+          <a:fillRef idx="1">
+            <a:schemeClr val="accent1"/>
+          </a:fillRef>
+          <a:effectRef idx="0">
+            <a:schemeClr val="accent1"/>
+          </a:effectRef>
+          <a:fontRef idx="minor">
+            <a:schemeClr val="lt1"/>
+          </a:fontRef>
+        </p:style>
+        <p:txBody>
+          <a:bodyPr rtlCol="0" anchor="ctr"/>
+          <a:lstStyle/>
+          <a:p>
+            <a:pPr algn="ctr"/>
+            <a:endParaRPr lang="en-US"/>
+          </a:p>
+        </p:txBody>
+      </p:sp>
+      <p:sp>
+        <p:nvSpPr>
+          <p:cNvPr id="85" name="Oval 84">
+            <a:extLst>
+              <a:ext uri="{FF2B5EF4-FFF2-40B4-BE49-F238E27FC236}">
+                <a16:creationId xmlns:a16="http://schemas.microsoft.com/office/drawing/2014/main" id="{152DDB61-DF23-0929-2B23-DAF0AE5B783A}"/>
+              </a:ext>
+            </a:extLst>
+          </p:cNvPr>
+          <p:cNvSpPr/>
+          <p:nvPr/>
+        </p:nvSpPr>
+        <p:spPr>
+          <a:xfrm>
+            <a:off x="9409484" y="5092160"/>
+            <a:ext cx="868721" cy="207555"/>
+          </a:xfrm>
+          <a:custGeom>
+            <a:avLst/>
+            <a:gdLst>
+              <a:gd name="csX0" fmla="*/ 0 w 801385"/>
+              <a:gd name="csY0" fmla="*/ 117946 h 235892"/>
+              <a:gd name="csX1" fmla="*/ 400693 w 801385"/>
+              <a:gd name="csY1" fmla="*/ 0 h 235892"/>
+              <a:gd name="csX2" fmla="*/ 801386 w 801385"/>
+              <a:gd name="csY2" fmla="*/ 117946 h 235892"/>
+              <a:gd name="csX3" fmla="*/ 400693 w 801385"/>
+              <a:gd name="csY3" fmla="*/ 235892 h 235892"/>
+              <a:gd name="csX4" fmla="*/ 0 w 801385"/>
+              <a:gd name="csY4" fmla="*/ 117946 h 235892"/>
+              <a:gd name="csX0" fmla="*/ 3 w 801389"/>
+              <a:gd name="csY0" fmla="*/ 117946 h 287263"/>
+              <a:gd name="csX1" fmla="*/ 400696 w 801389"/>
+              <a:gd name="csY1" fmla="*/ 0 h 287263"/>
+              <a:gd name="csX2" fmla="*/ 801389 w 801389"/>
+              <a:gd name="csY2" fmla="*/ 117946 h 287263"/>
+              <a:gd name="csX3" fmla="*/ 395559 w 801389"/>
+              <a:gd name="csY3" fmla="*/ 287263 h 287263"/>
+              <a:gd name="csX4" fmla="*/ 3 w 801389"/>
+              <a:gd name="csY4" fmla="*/ 117946 h 287263"/>
+              <a:gd name="csX0" fmla="*/ 0 w 801386"/>
+              <a:gd name="csY0" fmla="*/ 117946 h 310961"/>
+              <a:gd name="csX1" fmla="*/ 400693 w 801386"/>
+              <a:gd name="csY1" fmla="*/ 0 h 310961"/>
+              <a:gd name="csX2" fmla="*/ 801386 w 801386"/>
+              <a:gd name="csY2" fmla="*/ 117946 h 310961"/>
+              <a:gd name="csX3" fmla="*/ 395556 w 801386"/>
+              <a:gd name="csY3" fmla="*/ 287263 h 310961"/>
+              <a:gd name="csX4" fmla="*/ 400693 w 801386"/>
+              <a:gd name="csY4" fmla="*/ 291586 h 310961"/>
+              <a:gd name="csX5" fmla="*/ 0 w 801386"/>
+              <a:gd name="csY5" fmla="*/ 117946 h 310961"/>
+              <a:gd name="csX0" fmla="*/ 2200 w 803586"/>
+              <a:gd name="csY0" fmla="*/ 117946 h 310961"/>
+              <a:gd name="csX1" fmla="*/ 402893 w 803586"/>
+              <a:gd name="csY1" fmla="*/ 0 h 310961"/>
+              <a:gd name="csX2" fmla="*/ 803586 w 803586"/>
+              <a:gd name="csY2" fmla="*/ 117946 h 310961"/>
+              <a:gd name="csX3" fmla="*/ 397756 w 803586"/>
+              <a:gd name="csY3" fmla="*/ 287263 h 310961"/>
+              <a:gd name="csX4" fmla="*/ 248780 w 803586"/>
+              <a:gd name="csY4" fmla="*/ 291586 h 310961"/>
+              <a:gd name="csX5" fmla="*/ 2200 w 803586"/>
+              <a:gd name="csY5" fmla="*/ 117946 h 310961"/>
+              <a:gd name="csX0" fmla="*/ 2200 w 803586"/>
+              <a:gd name="csY0" fmla="*/ 117946 h 304150"/>
+              <a:gd name="csX1" fmla="*/ 402893 w 803586"/>
+              <a:gd name="csY1" fmla="*/ 0 h 304150"/>
+              <a:gd name="csX2" fmla="*/ 803586 w 803586"/>
+              <a:gd name="csY2" fmla="*/ 117946 h 304150"/>
+              <a:gd name="csX3" fmla="*/ 639199 w 803586"/>
+              <a:gd name="csY3" fmla="*/ 266714 h 304150"/>
+              <a:gd name="csX4" fmla="*/ 248780 w 803586"/>
+              <a:gd name="csY4" fmla="*/ 291586 h 304150"/>
+              <a:gd name="csX5" fmla="*/ 2200 w 803586"/>
+              <a:gd name="csY5" fmla="*/ 117946 h 304150"/>
+              <a:gd name="csX0" fmla="*/ 2200 w 803586"/>
+              <a:gd name="csY0" fmla="*/ 117946 h 298735"/>
+              <a:gd name="csX1" fmla="*/ 402893 w 803586"/>
+              <a:gd name="csY1" fmla="*/ 0 h 298735"/>
+              <a:gd name="csX2" fmla="*/ 803586 w 803586"/>
+              <a:gd name="csY2" fmla="*/ 117946 h 298735"/>
+              <a:gd name="csX3" fmla="*/ 639199 w 803586"/>
+              <a:gd name="csY3" fmla="*/ 266714 h 298735"/>
+              <a:gd name="csX4" fmla="*/ 248780 w 803586"/>
+              <a:gd name="csY4" fmla="*/ 291586 h 298735"/>
+              <a:gd name="csX5" fmla="*/ 2200 w 803586"/>
+              <a:gd name="csY5" fmla="*/ 117946 h 298735"/>
+              <a:gd name="csX0" fmla="*/ 2200 w 803586"/>
+              <a:gd name="csY0" fmla="*/ 117946 h 300374"/>
+              <a:gd name="csX1" fmla="*/ 402893 w 803586"/>
+              <a:gd name="csY1" fmla="*/ 0 h 300374"/>
+              <a:gd name="csX2" fmla="*/ 803586 w 803586"/>
+              <a:gd name="csY2" fmla="*/ 117946 h 300374"/>
+              <a:gd name="csX3" fmla="*/ 664884 w 803586"/>
+              <a:gd name="csY3" fmla="*/ 282125 h 300374"/>
+              <a:gd name="csX4" fmla="*/ 248780 w 803586"/>
+              <a:gd name="csY4" fmla="*/ 291586 h 300374"/>
+              <a:gd name="csX5" fmla="*/ 2200 w 803586"/>
+              <a:gd name="csY5" fmla="*/ 117946 h 300374"/>
+              <a:gd name="csX0" fmla="*/ 1898 w 839244"/>
+              <a:gd name="csY0" fmla="*/ 82591 h 300978"/>
+              <a:gd name="csX1" fmla="*/ 438551 w 839244"/>
+              <a:gd name="csY1" fmla="*/ 604 h 300978"/>
+              <a:gd name="csX2" fmla="*/ 839244 w 839244"/>
+              <a:gd name="csY2" fmla="*/ 118550 h 300978"/>
+              <a:gd name="csX3" fmla="*/ 700542 w 839244"/>
+              <a:gd name="csY3" fmla="*/ 282729 h 300978"/>
+              <a:gd name="csX4" fmla="*/ 284438 w 839244"/>
+              <a:gd name="csY4" fmla="*/ 292190 h 300978"/>
+              <a:gd name="csX5" fmla="*/ 1898 w 839244"/>
+              <a:gd name="csY5" fmla="*/ 82591 h 300978"/>
+              <a:gd name="csX0" fmla="*/ 12930 w 850276"/>
+              <a:gd name="csY0" fmla="*/ 82551 h 297947"/>
+              <a:gd name="csX1" fmla="*/ 449583 w 850276"/>
+              <a:gd name="csY1" fmla="*/ 564 h 297947"/>
+              <a:gd name="csX2" fmla="*/ 850276 w 850276"/>
+              <a:gd name="csY2" fmla="*/ 118510 h 297947"/>
+              <a:gd name="csX3" fmla="*/ 711574 w 850276"/>
+              <a:gd name="csY3" fmla="*/ 282689 h 297947"/>
+              <a:gd name="csX4" fmla="*/ 141358 w 850276"/>
+              <a:gd name="csY4" fmla="*/ 271602 h 297947"/>
+              <a:gd name="csX5" fmla="*/ 12930 w 850276"/>
+              <a:gd name="csY5" fmla="*/ 82551 h 297947"/>
+              <a:gd name="csX0" fmla="*/ 12930 w 891373"/>
+              <a:gd name="csY0" fmla="*/ 82191 h 298688"/>
+              <a:gd name="csX1" fmla="*/ 449583 w 891373"/>
+              <a:gd name="csY1" fmla="*/ 204 h 298688"/>
+              <a:gd name="csX2" fmla="*/ 891373 w 891373"/>
+              <a:gd name="csY2" fmla="*/ 102739 h 298688"/>
+              <a:gd name="csX3" fmla="*/ 711574 w 891373"/>
+              <a:gd name="csY3" fmla="*/ 282329 h 298688"/>
+              <a:gd name="csX4" fmla="*/ 141358 w 891373"/>
+              <a:gd name="csY4" fmla="*/ 271242 h 298688"/>
+              <a:gd name="csX5" fmla="*/ 12930 w 891373"/>
+              <a:gd name="csY5" fmla="*/ 82191 h 298688"/>
+              <a:gd name="csX0" fmla="*/ 13237 w 891680"/>
+              <a:gd name="csY0" fmla="*/ 14723 h 231220"/>
+              <a:gd name="csX1" fmla="*/ 455027 w 891680"/>
+              <a:gd name="csY1" fmla="*/ 14929 h 231220"/>
+              <a:gd name="csX2" fmla="*/ 891680 w 891680"/>
+              <a:gd name="csY2" fmla="*/ 35271 h 231220"/>
+              <a:gd name="csX3" fmla="*/ 711881 w 891680"/>
+              <a:gd name="csY3" fmla="*/ 214861 h 231220"/>
+              <a:gd name="csX4" fmla="*/ 141665 w 891680"/>
+              <a:gd name="csY4" fmla="*/ 203774 h 231220"/>
+              <a:gd name="csX5" fmla="*/ 13237 w 891680"/>
+              <a:gd name="csY5" fmla="*/ 14723 h 231220"/>
+              <a:gd name="csX0" fmla="*/ 13237 w 881406"/>
+              <a:gd name="csY0" fmla="*/ 16025 h 230326"/>
+              <a:gd name="csX1" fmla="*/ 455027 w 881406"/>
+              <a:gd name="csY1" fmla="*/ 16231 h 230326"/>
+              <a:gd name="csX2" fmla="*/ 881406 w 881406"/>
+              <a:gd name="csY2" fmla="*/ 67395 h 230326"/>
+              <a:gd name="csX3" fmla="*/ 711881 w 881406"/>
+              <a:gd name="csY3" fmla="*/ 216163 h 230326"/>
+              <a:gd name="csX4" fmla="*/ 141665 w 881406"/>
+              <a:gd name="csY4" fmla="*/ 205076 h 230326"/>
+              <a:gd name="csX5" fmla="*/ 13237 w 881406"/>
+              <a:gd name="csY5" fmla="*/ 16025 h 230326"/>
+              <a:gd name="csX0" fmla="*/ 13237 w 881406"/>
+              <a:gd name="csY0" fmla="*/ 16025 h 233398"/>
+              <a:gd name="csX1" fmla="*/ 455027 w 881406"/>
+              <a:gd name="csY1" fmla="*/ 16231 h 233398"/>
+              <a:gd name="csX2" fmla="*/ 881406 w 881406"/>
+              <a:gd name="csY2" fmla="*/ 67395 h 233398"/>
+              <a:gd name="csX3" fmla="*/ 717096 w 881406"/>
+              <a:gd name="csY3" fmla="*/ 220871 h 233398"/>
+              <a:gd name="csX4" fmla="*/ 141665 w 881406"/>
+              <a:gd name="csY4" fmla="*/ 205076 h 233398"/>
+              <a:gd name="csX5" fmla="*/ 13237 w 881406"/>
+              <a:gd name="csY5" fmla="*/ 16025 h 233398"/>
+              <a:gd name="csX0" fmla="*/ 13237 w 881406"/>
+              <a:gd name="csY0" fmla="*/ 16025 h 223358"/>
+              <a:gd name="csX1" fmla="*/ 455027 w 881406"/>
+              <a:gd name="csY1" fmla="*/ 16231 h 223358"/>
+              <a:gd name="csX2" fmla="*/ 881406 w 881406"/>
+              <a:gd name="csY2" fmla="*/ 67395 h 223358"/>
+              <a:gd name="csX3" fmla="*/ 717096 w 881406"/>
+              <a:gd name="csY3" fmla="*/ 220871 h 223358"/>
+              <a:gd name="csX4" fmla="*/ 141665 w 881406"/>
+              <a:gd name="csY4" fmla="*/ 205076 h 223358"/>
+              <a:gd name="csX5" fmla="*/ 13237 w 881406"/>
+              <a:gd name="csY5" fmla="*/ 16025 h 223358"/>
+              <a:gd name="csX0" fmla="*/ 13237 w 881406"/>
+              <a:gd name="csY0" fmla="*/ 16025 h 226968"/>
+              <a:gd name="csX1" fmla="*/ 455027 w 881406"/>
+              <a:gd name="csY1" fmla="*/ 16231 h 226968"/>
+              <a:gd name="csX2" fmla="*/ 881406 w 881406"/>
+              <a:gd name="csY2" fmla="*/ 67395 h 226968"/>
+              <a:gd name="csX3" fmla="*/ 717096 w 881406"/>
+              <a:gd name="csY3" fmla="*/ 220871 h 226968"/>
+              <a:gd name="csX4" fmla="*/ 141665 w 881406"/>
+              <a:gd name="csY4" fmla="*/ 205076 h 226968"/>
+              <a:gd name="csX5" fmla="*/ 13237 w 881406"/>
+              <a:gd name="csY5" fmla="*/ 16025 h 226968"/>
+              <a:gd name="csX0" fmla="*/ 13682 w 876636"/>
+              <a:gd name="csY0" fmla="*/ 42772 h 211337"/>
+              <a:gd name="csX1" fmla="*/ 450257 w 876636"/>
+              <a:gd name="csY1" fmla="*/ 600 h 211337"/>
+              <a:gd name="csX2" fmla="*/ 876636 w 876636"/>
+              <a:gd name="csY2" fmla="*/ 51764 h 211337"/>
+              <a:gd name="csX3" fmla="*/ 712326 w 876636"/>
+              <a:gd name="csY3" fmla="*/ 205240 h 211337"/>
+              <a:gd name="csX4" fmla="*/ 136895 w 876636"/>
+              <a:gd name="csY4" fmla="*/ 189445 h 211337"/>
+              <a:gd name="csX5" fmla="*/ 13682 w 876636"/>
+              <a:gd name="csY5" fmla="*/ 42772 h 211337"/>
+              <a:gd name="csX0" fmla="*/ 13364 w 876318"/>
+              <a:gd name="csY0" fmla="*/ 23517 h 192082"/>
+              <a:gd name="csX1" fmla="*/ 444722 w 876318"/>
+              <a:gd name="csY1" fmla="*/ 19015 h 192082"/>
+              <a:gd name="csX2" fmla="*/ 876318 w 876318"/>
+              <a:gd name="csY2" fmla="*/ 32509 h 192082"/>
+              <a:gd name="csX3" fmla="*/ 712008 w 876318"/>
+              <a:gd name="csY3" fmla="*/ 185985 h 192082"/>
+              <a:gd name="csX4" fmla="*/ 136577 w 876318"/>
+              <a:gd name="csY4" fmla="*/ 170190 h 192082"/>
+              <a:gd name="csX5" fmla="*/ 13364 w 876318"/>
+              <a:gd name="csY5" fmla="*/ 23517 h 192082"/>
+              <a:gd name="csX0" fmla="*/ 13364 w 850241"/>
+              <a:gd name="csY0" fmla="*/ 14305 h 190082"/>
+              <a:gd name="csX1" fmla="*/ 444722 w 850241"/>
+              <a:gd name="csY1" fmla="*/ 9803 h 190082"/>
+              <a:gd name="csX2" fmla="*/ 850241 w 850241"/>
+              <a:gd name="csY2" fmla="*/ 51550 h 190082"/>
+              <a:gd name="csX3" fmla="*/ 712008 w 850241"/>
+              <a:gd name="csY3" fmla="*/ 176773 h 190082"/>
+              <a:gd name="csX4" fmla="*/ 136577 w 850241"/>
+              <a:gd name="csY4" fmla="*/ 160978 h 190082"/>
+              <a:gd name="csX5" fmla="*/ 13364 w 850241"/>
+              <a:gd name="csY5" fmla="*/ 14305 h 190082"/>
+              <a:gd name="csX0" fmla="*/ 13364 w 881533"/>
+              <a:gd name="csY0" fmla="*/ 13820 h 190246"/>
+              <a:gd name="csX1" fmla="*/ 444722 w 881533"/>
+              <a:gd name="csY1" fmla="*/ 9318 h 190246"/>
+              <a:gd name="csX2" fmla="*/ 881533 w 881533"/>
+              <a:gd name="csY2" fmla="*/ 41647 h 190246"/>
+              <a:gd name="csX3" fmla="*/ 712008 w 881533"/>
+              <a:gd name="csY3" fmla="*/ 176288 h 190246"/>
+              <a:gd name="csX4" fmla="*/ 136577 w 881533"/>
+              <a:gd name="csY4" fmla="*/ 160493 h 190246"/>
+              <a:gd name="csX5" fmla="*/ 13364 w 881533"/>
+              <a:gd name="csY5" fmla="*/ 13820 h 190246"/>
+              <a:gd name="csX0" fmla="*/ 13364 w 881533"/>
+              <a:gd name="csY0" fmla="*/ 13820 h 190246"/>
+              <a:gd name="csX1" fmla="*/ 444722 w 881533"/>
+              <a:gd name="csY1" fmla="*/ 9318 h 190246"/>
+              <a:gd name="csX2" fmla="*/ 881533 w 881533"/>
+              <a:gd name="csY2" fmla="*/ 41647 h 190246"/>
+              <a:gd name="csX3" fmla="*/ 712008 w 881533"/>
+              <a:gd name="csY3" fmla="*/ 176288 h 190246"/>
+              <a:gd name="csX4" fmla="*/ 136577 w 881533"/>
+              <a:gd name="csY4" fmla="*/ 160493 h 190246"/>
+              <a:gd name="csX5" fmla="*/ 13364 w 881533"/>
+              <a:gd name="csY5" fmla="*/ 13820 h 190246"/>
+              <a:gd name="csX0" fmla="*/ 13796 w 881965"/>
+              <a:gd name="csY0" fmla="*/ 13820 h 190246"/>
+              <a:gd name="csX1" fmla="*/ 445154 w 881965"/>
+              <a:gd name="csY1" fmla="*/ 9318 h 190246"/>
+              <a:gd name="csX2" fmla="*/ 881965 w 881965"/>
+              <a:gd name="csY2" fmla="*/ 41647 h 190246"/>
+              <a:gd name="csX3" fmla="*/ 712440 w 881965"/>
+              <a:gd name="csY3" fmla="*/ 176288 h 190246"/>
+              <a:gd name="csX4" fmla="*/ 137009 w 881965"/>
+              <a:gd name="csY4" fmla="*/ 160493 h 190246"/>
+              <a:gd name="csX5" fmla="*/ 13796 w 881965"/>
+              <a:gd name="csY5" fmla="*/ 13820 h 190246"/>
+            </a:gdLst>
+            <a:ahLst/>
+            <a:cxnLst>
+              <a:cxn ang="0">
+                <a:pos x="csX0" y="csY0"/>
+              </a:cxn>
+              <a:cxn ang="0">
+                <a:pos x="csX1" y="csY1"/>
+              </a:cxn>
+              <a:cxn ang="0">
+                <a:pos x="csX2" y="csY2"/>
+              </a:cxn>
+              <a:cxn ang="0">
+                <a:pos x="csX3" y="csY3"/>
+              </a:cxn>
+              <a:cxn ang="0">
+                <a:pos x="csX4" y="csY4"/>
+              </a:cxn>
+              <a:cxn ang="0">
+                <a:pos x="csX5" y="csY5"/>
+              </a:cxn>
+            </a:cxnLst>
+            <a:rect l="l" t="t" r="r" b="b"/>
+            <a:pathLst>
+              <a:path w="881965" h="190246">
+                <a:moveTo>
+                  <a:pt x="13796" y="13820"/>
+                </a:moveTo>
+                <a:cubicBezTo>
+                  <a:pt x="65154" y="-11376"/>
+                  <a:pt x="300459" y="4680"/>
+                  <a:pt x="445154" y="9318"/>
+                </a:cubicBezTo>
+                <a:cubicBezTo>
+                  <a:pt x="589849" y="13956"/>
+                  <a:pt x="881965" y="-23493"/>
+                  <a:pt x="881965" y="41647"/>
+                </a:cubicBezTo>
+                <a:cubicBezTo>
+                  <a:pt x="829812" y="116204"/>
+                  <a:pt x="836599" y="156480"/>
+                  <a:pt x="712440" y="176288"/>
+                </a:cubicBezTo>
+                <a:cubicBezTo>
+                  <a:pt x="588281" y="196096"/>
+                  <a:pt x="213365" y="198130"/>
+                  <a:pt x="137009" y="160493"/>
+                </a:cubicBezTo>
+                <a:cubicBezTo>
+                  <a:pt x="65868" y="160527"/>
+                  <a:pt x="-37562" y="39016"/>
+                  <a:pt x="13796" y="13820"/>
+                </a:cubicBezTo>
+                <a:close/>
+              </a:path>
+            </a:pathLst>
+          </a:custGeom>
+          <a:pattFill prst="wave">
+            <a:fgClr>
+              <a:schemeClr val="tx2">
+                <a:lumMod val="75000"/>
+                <a:lumOff val="25000"/>
+              </a:schemeClr>
+            </a:fgClr>
+            <a:bgClr>
+              <a:schemeClr val="bg1"/>
+            </a:bgClr>
+          </a:pattFill>
+          <a:ln>
+            <a:solidFill>
+              <a:schemeClr val="tx2">
+                <a:lumMod val="25000"/>
+                <a:lumOff val="75000"/>
+              </a:schemeClr>
+            </a:solidFill>
+          </a:ln>
+        </p:spPr>
+        <p:style>
+          <a:lnRef idx="2">
+            <a:schemeClr val="accent1">
+              <a:shade val="15000"/>
+            </a:schemeClr>
+          </a:lnRef>
+          <a:fillRef idx="1">
+            <a:schemeClr val="accent1"/>
+          </a:fillRef>
+          <a:effectRef idx="0">
+            <a:schemeClr val="accent1"/>
+          </a:effectRef>
+          <a:fontRef idx="minor">
+            <a:schemeClr val="lt1"/>
+          </a:fontRef>
+        </p:style>
+        <p:txBody>
+          <a:bodyPr rtlCol="0" anchor="ctr"/>
+          <a:lstStyle/>
+          <a:p>
+            <a:pPr algn="ctr"/>
+            <a:endParaRPr lang="en-US"/>
+          </a:p>
+        </p:txBody>
+      </p:sp>
+      <p:sp>
+        <p:nvSpPr>
+          <p:cNvPr id="99" name="Oval 98">
+            <a:extLst>
+              <a:ext uri="{FF2B5EF4-FFF2-40B4-BE49-F238E27FC236}">
+                <a16:creationId xmlns:a16="http://schemas.microsoft.com/office/drawing/2014/main" id="{C9D9AE58-1BD0-B764-DE4C-C30E4F8CB07E}"/>
+              </a:ext>
+            </a:extLst>
+          </p:cNvPr>
+          <p:cNvSpPr/>
+          <p:nvPr/>
+        </p:nvSpPr>
+        <p:spPr>
+          <a:xfrm>
+            <a:off x="7152230" y="5026544"/>
+            <a:ext cx="1216668" cy="124547"/>
+          </a:xfrm>
+          <a:custGeom>
+            <a:avLst/>
+            <a:gdLst>
+              <a:gd name="csX0" fmla="*/ 0 w 1216668"/>
+              <a:gd name="csY0" fmla="*/ 62274 h 124547"/>
+              <a:gd name="csX1" fmla="*/ 608334 w 1216668"/>
+              <a:gd name="csY1" fmla="*/ 0 h 124547"/>
+              <a:gd name="csX2" fmla="*/ 1216668 w 1216668"/>
+              <a:gd name="csY2" fmla="*/ 62274 h 124547"/>
+              <a:gd name="csX3" fmla="*/ 608334 w 1216668"/>
+              <a:gd name="csY3" fmla="*/ 124548 h 124547"/>
+              <a:gd name="csX4" fmla="*/ 0 w 1216668"/>
+              <a:gd name="csY4" fmla="*/ 62274 h 124547"/>
+            </a:gdLst>
+            <a:ahLst/>
+            <a:cxnLst>
+              <a:cxn ang="0">
+                <a:pos x="csX0" y="csY0"/>
+              </a:cxn>
+              <a:cxn ang="0">
+                <a:pos x="csX1" y="csY1"/>
+              </a:cxn>
+              <a:cxn ang="0">
+                <a:pos x="csX2" y="csY2"/>
+              </a:cxn>
+              <a:cxn ang="0">
+                <a:pos x="csX3" y="csY3"/>
+              </a:cxn>
+              <a:cxn ang="0">
+                <a:pos x="csX4" y="csY4"/>
+              </a:cxn>
+            </a:cxnLst>
+            <a:rect l="l" t="t" r="r" b="b"/>
+            <a:pathLst>
+              <a:path w="1216668" h="124547" fill="none" extrusionOk="0">
+                <a:moveTo>
+                  <a:pt x="0" y="62274"/>
+                </a:moveTo>
+                <a:cubicBezTo>
+                  <a:pt x="69609" y="36139"/>
+                  <a:pt x="283941" y="-23834"/>
+                  <a:pt x="608334" y="0"/>
+                </a:cubicBezTo>
+                <a:cubicBezTo>
+                  <a:pt x="942198" y="-323"/>
+                  <a:pt x="1210380" y="33802"/>
+                  <a:pt x="1216668" y="62274"/>
+                </a:cubicBezTo>
+                <a:cubicBezTo>
+                  <a:pt x="1210321" y="36137"/>
+                  <a:pt x="897461" y="189653"/>
+                  <a:pt x="608334" y="124548"/>
+                </a:cubicBezTo>
+                <a:cubicBezTo>
+                  <a:pt x="280563" y="129141"/>
+                  <a:pt x="4593" y="97771"/>
+                  <a:pt x="0" y="62274"/>
+                </a:cubicBezTo>
+                <a:close/>
+              </a:path>
+              <a:path w="1216668" h="124547" stroke="0" extrusionOk="0">
+                <a:moveTo>
+                  <a:pt x="0" y="62274"/>
+                </a:moveTo>
+                <a:cubicBezTo>
+                  <a:pt x="-63163" y="-11080"/>
+                  <a:pt x="241817" y="11463"/>
+                  <a:pt x="608334" y="0"/>
+                </a:cubicBezTo>
+                <a:cubicBezTo>
+                  <a:pt x="948882" y="963"/>
+                  <a:pt x="1213890" y="27969"/>
+                  <a:pt x="1216668" y="62274"/>
+                </a:cubicBezTo>
+                <a:cubicBezTo>
+                  <a:pt x="1184160" y="128413"/>
+                  <a:pt x="936241" y="169138"/>
+                  <a:pt x="608334" y="124548"/>
+                </a:cubicBezTo>
+                <a:cubicBezTo>
+                  <a:pt x="266206" y="121181"/>
+                  <a:pt x="2457" y="97841"/>
+                  <a:pt x="0" y="62274"/>
+                </a:cubicBezTo>
+                <a:close/>
+              </a:path>
+            </a:pathLst>
+          </a:custGeom>
+          <a:noFill/>
+          <a:ln>
+            <a:solidFill>
+              <a:schemeClr val="accent1">
+                <a:lumMod val="60000"/>
+                <a:lumOff val="40000"/>
+              </a:schemeClr>
+            </a:solidFill>
+            <a:prstDash val="sysDot"/>
+            <a:extLst>
+              <a:ext uri="{C807C97D-BFC1-408E-A445-0C87EB9F89A2}">
+                <ask:lineSketchStyleProps xmlns:ask="http://schemas.microsoft.com/office/drawing/2018/sketchyshapes" sd="1219033472">
+                  <a:prstGeom prst="ellipse">
+                    <a:avLst/>
+                  </a:prstGeom>
+                  <ask:type>
+                    <ask:lineSketchScribble/>
+                  </ask:type>
+                </ask:lineSketchStyleProps>
+              </a:ext>
+            </a:extLst>
+          </a:ln>
+        </p:spPr>
+        <p:style>
+          <a:lnRef idx="2">
+            <a:schemeClr val="accent1">
+              <a:shade val="15000"/>
+            </a:schemeClr>
+          </a:lnRef>
+          <a:fillRef idx="1">
+            <a:schemeClr val="accent1"/>
+          </a:fillRef>
+          <a:effectRef idx="0">
+            <a:schemeClr val="accent1"/>
+          </a:effectRef>
+          <a:fontRef idx="minor">
+            <a:schemeClr val="lt1"/>
+          </a:fontRef>
+        </p:style>
+        <p:txBody>
+          <a:bodyPr rtlCol="0" anchor="ctr"/>
+          <a:lstStyle/>
+          <a:p>
+            <a:pPr algn="ctr"/>
+            <a:endParaRPr lang="en-US"/>
+          </a:p>
+        </p:txBody>
+      </p:sp>
+      <p:sp>
+        <p:nvSpPr>
+          <p:cNvPr id="100" name="Oval 99">
+            <a:extLst>
+              <a:ext uri="{FF2B5EF4-FFF2-40B4-BE49-F238E27FC236}">
+                <a16:creationId xmlns:a16="http://schemas.microsoft.com/office/drawing/2014/main" id="{CF8FF871-E591-3B6F-4834-32F5C746EA7B}"/>
+              </a:ext>
+            </a:extLst>
+          </p:cNvPr>
+          <p:cNvSpPr/>
+          <p:nvPr/>
+        </p:nvSpPr>
+        <p:spPr>
+          <a:xfrm>
+            <a:off x="9229017" y="5360311"/>
+            <a:ext cx="1216663" cy="128248"/>
+          </a:xfrm>
+          <a:custGeom>
+            <a:avLst/>
+            <a:gdLst>
+              <a:gd name="csX0" fmla="*/ 0 w 1216663"/>
+              <a:gd name="csY0" fmla="*/ 64124 h 128248"/>
+              <a:gd name="csX1" fmla="*/ 608332 w 1216663"/>
+              <a:gd name="csY1" fmla="*/ 0 h 128248"/>
+              <a:gd name="csX2" fmla="*/ 1216664 w 1216663"/>
+              <a:gd name="csY2" fmla="*/ 64124 h 128248"/>
+              <a:gd name="csX3" fmla="*/ 608332 w 1216663"/>
+              <a:gd name="csY3" fmla="*/ 128248 h 128248"/>
+              <a:gd name="csX4" fmla="*/ 0 w 1216663"/>
+              <a:gd name="csY4" fmla="*/ 64124 h 128248"/>
+            </a:gdLst>
+            <a:ahLst/>
+            <a:cxnLst>
+              <a:cxn ang="0">
+                <a:pos x="csX0" y="csY0"/>
+              </a:cxn>
+              <a:cxn ang="0">
+                <a:pos x="csX1" y="csY1"/>
+              </a:cxn>
+              <a:cxn ang="0">
+                <a:pos x="csX2" y="csY2"/>
+              </a:cxn>
+              <a:cxn ang="0">
+                <a:pos x="csX3" y="csY3"/>
+              </a:cxn>
+              <a:cxn ang="0">
+                <a:pos x="csX4" y="csY4"/>
+              </a:cxn>
+            </a:cxnLst>
+            <a:rect l="l" t="t" r="r" b="b"/>
+            <a:pathLst>
+              <a:path w="1216663" h="128248" fill="none" extrusionOk="0">
+                <a:moveTo>
+                  <a:pt x="0" y="64124"/>
+                </a:moveTo>
+                <a:cubicBezTo>
+                  <a:pt x="33571" y="32692"/>
+                  <a:pt x="283495" y="-22915"/>
+                  <a:pt x="608332" y="0"/>
+                </a:cubicBezTo>
+                <a:cubicBezTo>
+                  <a:pt x="937376" y="-1061"/>
+                  <a:pt x="1213975" y="31241"/>
+                  <a:pt x="1216664" y="64124"/>
+                </a:cubicBezTo>
+                <a:cubicBezTo>
+                  <a:pt x="1215038" y="84030"/>
+                  <a:pt x="930887" y="146893"/>
+                  <a:pt x="608332" y="128248"/>
+                </a:cubicBezTo>
+                <a:cubicBezTo>
+                  <a:pt x="274924" y="129683"/>
+                  <a:pt x="1346" y="99863"/>
+                  <a:pt x="0" y="64124"/>
+                </a:cubicBezTo>
+                <a:close/>
+              </a:path>
+              <a:path w="1216663" h="128248" stroke="0" extrusionOk="0">
+                <a:moveTo>
+                  <a:pt x="0" y="64124"/>
+                </a:moveTo>
+                <a:cubicBezTo>
+                  <a:pt x="-29864" y="10288"/>
+                  <a:pt x="234528" y="14199"/>
+                  <a:pt x="608332" y="0"/>
+                </a:cubicBezTo>
+                <a:cubicBezTo>
+                  <a:pt x="945248" y="199"/>
+                  <a:pt x="1209506" y="28937"/>
+                  <a:pt x="1216664" y="64124"/>
+                </a:cubicBezTo>
+                <a:cubicBezTo>
+                  <a:pt x="1188848" y="126703"/>
+                  <a:pt x="938501" y="160322"/>
+                  <a:pt x="608332" y="128248"/>
+                </a:cubicBezTo>
+                <a:cubicBezTo>
+                  <a:pt x="267581" y="125633"/>
+                  <a:pt x="1784" y="100391"/>
+                  <a:pt x="0" y="64124"/>
+                </a:cubicBezTo>
+                <a:close/>
+              </a:path>
+            </a:pathLst>
+          </a:custGeom>
+          <a:noFill/>
+          <a:ln cmpd="sng">
+            <a:solidFill>
+              <a:schemeClr val="accent1">
+                <a:lumMod val="60000"/>
+                <a:lumOff val="40000"/>
+              </a:schemeClr>
+            </a:solidFill>
+            <a:prstDash val="sysDot"/>
+            <a:miter lim="800000"/>
+            <a:extLst>
+              <a:ext uri="{C807C97D-BFC1-408E-A445-0C87EB9F89A2}">
+                <ask:lineSketchStyleProps xmlns:ask="http://schemas.microsoft.com/office/drawing/2018/sketchyshapes" sd="1219033472">
+                  <a:prstGeom prst="ellipse">
+                    <a:avLst/>
+                  </a:prstGeom>
+                  <ask:type>
+                    <ask:lineSketchFreehand/>
+                  </ask:type>
+                </ask:lineSketchStyleProps>
+              </a:ext>
+            </a:extLst>
+          </a:ln>
+        </p:spPr>
+        <p:style>
+          <a:lnRef idx="2">
+            <a:schemeClr val="accent1">
+              <a:shade val="15000"/>
+            </a:schemeClr>
+          </a:lnRef>
+          <a:fillRef idx="1">
+            <a:schemeClr val="accent1"/>
+          </a:fillRef>
+          <a:effectRef idx="0">
+            <a:schemeClr val="accent1"/>
+          </a:effectRef>
+          <a:fontRef idx="minor">
+            <a:schemeClr val="lt1"/>
+          </a:fontRef>
+        </p:style>
+        <p:txBody>
+          <a:bodyPr rtlCol="0" anchor="ctr"/>
+          <a:lstStyle/>
+          <a:p>
+            <a:pPr algn="ctr"/>
+            <a:endParaRPr lang="en-US"/>
+          </a:p>
+        </p:txBody>
+      </p:sp>
+      <p:sp>
+        <p:nvSpPr>
+          <p:cNvPr id="72" name="Freeform 71">
+            <a:extLst>
+              <a:ext uri="{FF2B5EF4-FFF2-40B4-BE49-F238E27FC236}">
+                <a16:creationId xmlns:a16="http://schemas.microsoft.com/office/drawing/2014/main" id="{D4C38097-2D01-A68E-0E3E-F18E8839C665}"/>
+              </a:ext>
+            </a:extLst>
+          </p:cNvPr>
+          <p:cNvSpPr/>
+          <p:nvPr/>
+        </p:nvSpPr>
+        <p:spPr>
+          <a:xfrm rot="583769">
+            <a:off x="7020468" y="4277925"/>
+            <a:ext cx="3500371" cy="881393"/>
           </a:xfrm>
           <a:custGeom>
             <a:avLst/>
@@ -6426,6 +7721,168 @@
               <a:gd name="csY7" fmla="*/ 1094914 h 1893064"/>
               <a:gd name="csX8" fmla="*/ 3500370 w 3500370"/>
               <a:gd name="csY8" fmla="*/ 544638 h 1893064"/>
+              <a:gd name="csX0" fmla="*/ 0 w 3500370"/>
+              <a:gd name="csY0" fmla="*/ 196605 h 1180180"/>
+              <a:gd name="csX1" fmla="*/ 534438 w 3500370"/>
+              <a:gd name="csY1" fmla="*/ 101456 h 1180180"/>
+              <a:gd name="csX2" fmla="*/ 771417 w 3500370"/>
+              <a:gd name="csY2" fmla="*/ 606688 h 1180180"/>
+              <a:gd name="csX3" fmla="*/ 1296588 w 3500370"/>
+              <a:gd name="csY3" fmla="*/ 40351 h 1180180"/>
+              <a:gd name="csX4" fmla="*/ 1743739 w 3500370"/>
+              <a:gd name="csY4" fmla="*/ 239136 h 1180180"/>
+              <a:gd name="csX5" fmla="*/ 2159260 w 3500370"/>
+              <a:gd name="csY5" fmla="*/ 36015 h 1180180"/>
+              <a:gd name="csX6" fmla="*/ 2504811 w 3500370"/>
+              <a:gd name="csY6" fmla="*/ 1119701 h 1180180"/>
+              <a:gd name="csX7" fmla="*/ 3175841 w 3500370"/>
+              <a:gd name="csY7" fmla="*/ 1052144 h 1180180"/>
+              <a:gd name="csX8" fmla="*/ 3500370 w 3500370"/>
+              <a:gd name="csY8" fmla="*/ 501868 h 1180180"/>
+              <a:gd name="csX0" fmla="*/ 0 w 3500370"/>
+              <a:gd name="csY0" fmla="*/ 196605 h 1180180"/>
+              <a:gd name="csX1" fmla="*/ 422052 w 3500370"/>
+              <a:gd name="csY1" fmla="*/ 19221 h 1180180"/>
+              <a:gd name="csX2" fmla="*/ 771417 w 3500370"/>
+              <a:gd name="csY2" fmla="*/ 606688 h 1180180"/>
+              <a:gd name="csX3" fmla="*/ 1296588 w 3500370"/>
+              <a:gd name="csY3" fmla="*/ 40351 h 1180180"/>
+              <a:gd name="csX4" fmla="*/ 1743739 w 3500370"/>
+              <a:gd name="csY4" fmla="*/ 239136 h 1180180"/>
+              <a:gd name="csX5" fmla="*/ 2159260 w 3500370"/>
+              <a:gd name="csY5" fmla="*/ 36015 h 1180180"/>
+              <a:gd name="csX6" fmla="*/ 2504811 w 3500370"/>
+              <a:gd name="csY6" fmla="*/ 1119701 h 1180180"/>
+              <a:gd name="csX7" fmla="*/ 3175841 w 3500370"/>
+              <a:gd name="csY7" fmla="*/ 1052144 h 1180180"/>
+              <a:gd name="csX8" fmla="*/ 3500370 w 3500370"/>
+              <a:gd name="csY8" fmla="*/ 501868 h 1180180"/>
+              <a:gd name="csX0" fmla="*/ 0 w 3500370"/>
+              <a:gd name="csY0" fmla="*/ 238981 h 1222556"/>
+              <a:gd name="csX1" fmla="*/ 422052 w 3500370"/>
+              <a:gd name="csY1" fmla="*/ 61597 h 1222556"/>
+              <a:gd name="csX2" fmla="*/ 771417 w 3500370"/>
+              <a:gd name="csY2" fmla="*/ 649064 h 1222556"/>
+              <a:gd name="csX3" fmla="*/ 1296588 w 3500370"/>
+              <a:gd name="csY3" fmla="*/ 82727 h 1222556"/>
+              <a:gd name="csX4" fmla="*/ 1743739 w 3500370"/>
+              <a:gd name="csY4" fmla="*/ 281512 h 1222556"/>
+              <a:gd name="csX5" fmla="*/ 2159260 w 3500370"/>
+              <a:gd name="csY5" fmla="*/ 78391 h 1222556"/>
+              <a:gd name="csX6" fmla="*/ 2504811 w 3500370"/>
+              <a:gd name="csY6" fmla="*/ 1162077 h 1222556"/>
+              <a:gd name="csX7" fmla="*/ 3175841 w 3500370"/>
+              <a:gd name="csY7" fmla="*/ 1094520 h 1222556"/>
+              <a:gd name="csX8" fmla="*/ 3500370 w 3500370"/>
+              <a:gd name="csY8" fmla="*/ 544244 h 1222556"/>
+              <a:gd name="csX0" fmla="*/ 0 w 3500370"/>
+              <a:gd name="csY0" fmla="*/ 225835 h 1209410"/>
+              <a:gd name="csX1" fmla="*/ 447585 w 3500370"/>
+              <a:gd name="csY1" fmla="*/ 64173 h 1209410"/>
+              <a:gd name="csX2" fmla="*/ 771417 w 3500370"/>
+              <a:gd name="csY2" fmla="*/ 635918 h 1209410"/>
+              <a:gd name="csX3" fmla="*/ 1296588 w 3500370"/>
+              <a:gd name="csY3" fmla="*/ 69581 h 1209410"/>
+              <a:gd name="csX4" fmla="*/ 1743739 w 3500370"/>
+              <a:gd name="csY4" fmla="*/ 268366 h 1209410"/>
+              <a:gd name="csX5" fmla="*/ 2159260 w 3500370"/>
+              <a:gd name="csY5" fmla="*/ 65245 h 1209410"/>
+              <a:gd name="csX6" fmla="*/ 2504811 w 3500370"/>
+              <a:gd name="csY6" fmla="*/ 1148931 h 1209410"/>
+              <a:gd name="csX7" fmla="*/ 3175841 w 3500370"/>
+              <a:gd name="csY7" fmla="*/ 1081374 h 1209410"/>
+              <a:gd name="csX8" fmla="*/ 3500370 w 3500370"/>
+              <a:gd name="csY8" fmla="*/ 531098 h 1209410"/>
+              <a:gd name="csX0" fmla="*/ 0 w 3500370"/>
+              <a:gd name="csY0" fmla="*/ 225835 h 1209410"/>
+              <a:gd name="csX1" fmla="*/ 447585 w 3500370"/>
+              <a:gd name="csY1" fmla="*/ 64173 h 1209410"/>
+              <a:gd name="csX2" fmla="*/ 771417 w 3500370"/>
+              <a:gd name="csY2" fmla="*/ 635918 h 1209410"/>
+              <a:gd name="csX3" fmla="*/ 1360308 w 3500370"/>
+              <a:gd name="csY3" fmla="*/ 76230 h 1209410"/>
+              <a:gd name="csX4" fmla="*/ 1743739 w 3500370"/>
+              <a:gd name="csY4" fmla="*/ 268366 h 1209410"/>
+              <a:gd name="csX5" fmla="*/ 2159260 w 3500370"/>
+              <a:gd name="csY5" fmla="*/ 65245 h 1209410"/>
+              <a:gd name="csX6" fmla="*/ 2504811 w 3500370"/>
+              <a:gd name="csY6" fmla="*/ 1148931 h 1209410"/>
+              <a:gd name="csX7" fmla="*/ 3175841 w 3500370"/>
+              <a:gd name="csY7" fmla="*/ 1081374 h 1209410"/>
+              <a:gd name="csX8" fmla="*/ 3500370 w 3500370"/>
+              <a:gd name="csY8" fmla="*/ 531098 h 1209410"/>
+              <a:gd name="csX0" fmla="*/ 0 w 3500370"/>
+              <a:gd name="csY0" fmla="*/ 225835 h 1209410"/>
+              <a:gd name="csX1" fmla="*/ 447585 w 3500370"/>
+              <a:gd name="csY1" fmla="*/ 64173 h 1209410"/>
+              <a:gd name="csX2" fmla="*/ 771417 w 3500370"/>
+              <a:gd name="csY2" fmla="*/ 635918 h 1209410"/>
+              <a:gd name="csX3" fmla="*/ 1318191 w 3500370"/>
+              <a:gd name="csY3" fmla="*/ 53556 h 1209410"/>
+              <a:gd name="csX4" fmla="*/ 1743739 w 3500370"/>
+              <a:gd name="csY4" fmla="*/ 268366 h 1209410"/>
+              <a:gd name="csX5" fmla="*/ 2159260 w 3500370"/>
+              <a:gd name="csY5" fmla="*/ 65245 h 1209410"/>
+              <a:gd name="csX6" fmla="*/ 2504811 w 3500370"/>
+              <a:gd name="csY6" fmla="*/ 1148931 h 1209410"/>
+              <a:gd name="csX7" fmla="*/ 3175841 w 3500370"/>
+              <a:gd name="csY7" fmla="*/ 1081374 h 1209410"/>
+              <a:gd name="csX8" fmla="*/ 3500370 w 3500370"/>
+              <a:gd name="csY8" fmla="*/ 531098 h 1209410"/>
+              <a:gd name="csX0" fmla="*/ 0 w 3500370"/>
+              <a:gd name="csY0" fmla="*/ 196406 h 1179981"/>
+              <a:gd name="csX1" fmla="*/ 447585 w 3500370"/>
+              <a:gd name="csY1" fmla="*/ 34744 h 1179981"/>
+              <a:gd name="csX2" fmla="*/ 690734 w 3500370"/>
+              <a:gd name="csY2" fmla="*/ 668503 h 1179981"/>
+              <a:gd name="csX3" fmla="*/ 1318191 w 3500370"/>
+              <a:gd name="csY3" fmla="*/ 24127 h 1179981"/>
+              <a:gd name="csX4" fmla="*/ 1743739 w 3500370"/>
+              <a:gd name="csY4" fmla="*/ 238937 h 1179981"/>
+              <a:gd name="csX5" fmla="*/ 2159260 w 3500370"/>
+              <a:gd name="csY5" fmla="*/ 35816 h 1179981"/>
+              <a:gd name="csX6" fmla="*/ 2504811 w 3500370"/>
+              <a:gd name="csY6" fmla="*/ 1119502 h 1179981"/>
+              <a:gd name="csX7" fmla="*/ 3175841 w 3500370"/>
+              <a:gd name="csY7" fmla="*/ 1051945 h 1179981"/>
+              <a:gd name="csX8" fmla="*/ 3500370 w 3500370"/>
+              <a:gd name="csY8" fmla="*/ 501669 h 1179981"/>
+              <a:gd name="csX0" fmla="*/ 0 w 3500370"/>
+              <a:gd name="csY0" fmla="*/ 219494 h 1203069"/>
+              <a:gd name="csX1" fmla="*/ 425267 w 3500370"/>
+              <a:gd name="csY1" fmla="*/ 20286 h 1203069"/>
+              <a:gd name="csX2" fmla="*/ 690734 w 3500370"/>
+              <a:gd name="csY2" fmla="*/ 691591 h 1203069"/>
+              <a:gd name="csX3" fmla="*/ 1318191 w 3500370"/>
+              <a:gd name="csY3" fmla="*/ 47215 h 1203069"/>
+              <a:gd name="csX4" fmla="*/ 1743739 w 3500370"/>
+              <a:gd name="csY4" fmla="*/ 262025 h 1203069"/>
+              <a:gd name="csX5" fmla="*/ 2159260 w 3500370"/>
+              <a:gd name="csY5" fmla="*/ 58904 h 1203069"/>
+              <a:gd name="csX6" fmla="*/ 2504811 w 3500370"/>
+              <a:gd name="csY6" fmla="*/ 1142590 h 1203069"/>
+              <a:gd name="csX7" fmla="*/ 3175841 w 3500370"/>
+              <a:gd name="csY7" fmla="*/ 1075033 h 1203069"/>
+              <a:gd name="csX8" fmla="*/ 3500370 w 3500370"/>
+              <a:gd name="csY8" fmla="*/ 524757 h 1203069"/>
+              <a:gd name="csX0" fmla="*/ 0 w 3500370"/>
+              <a:gd name="csY0" fmla="*/ 237619 h 1221194"/>
+              <a:gd name="csX1" fmla="*/ 425267 w 3500370"/>
+              <a:gd name="csY1" fmla="*/ 38411 h 1221194"/>
+              <a:gd name="csX2" fmla="*/ 690734 w 3500370"/>
+              <a:gd name="csY2" fmla="*/ 709716 h 1221194"/>
+              <a:gd name="csX3" fmla="*/ 1318191 w 3500370"/>
+              <a:gd name="csY3" fmla="*/ 65340 h 1221194"/>
+              <a:gd name="csX4" fmla="*/ 1743739 w 3500370"/>
+              <a:gd name="csY4" fmla="*/ 280150 h 1221194"/>
+              <a:gd name="csX5" fmla="*/ 2159260 w 3500370"/>
+              <a:gd name="csY5" fmla="*/ 77029 h 1221194"/>
+              <a:gd name="csX6" fmla="*/ 2504811 w 3500370"/>
+              <a:gd name="csY6" fmla="*/ 1160715 h 1221194"/>
+              <a:gd name="csX7" fmla="*/ 3175841 w 3500370"/>
+              <a:gd name="csY7" fmla="*/ 1093158 h 1221194"/>
+              <a:gd name="csX8" fmla="*/ 3500370 w 3500370"/>
+              <a:gd name="csY8" fmla="*/ 542882 h 1221194"/>
             </a:gdLst>
             <a:ahLst/>
             <a:cxnLst>
@@ -6459,49 +7916,49 @@
             </a:cxnLst>
             <a:rect l="l" t="t" r="r" b="b"/>
             <a:pathLst>
-              <a:path w="3500370" h="1893064">
+              <a:path w="3500370" h="1221194">
                 <a:moveTo>
-                  <a:pt x="0" y="239375"/>
+                  <a:pt x="0" y="237619"/>
                 </a:moveTo>
                 <a:cubicBezTo>
-                  <a:pt x="168348" y="129505"/>
-                  <a:pt x="338288" y="-131380"/>
-                  <a:pt x="534438" y="144226"/>
-                </a:cubicBezTo>
-                <a:cubicBezTo>
-                  <a:pt x="730588" y="419832"/>
-                  <a:pt x="1049876" y="1903196"/>
-                  <a:pt x="1176901" y="1893012"/>
-                </a:cubicBezTo>
-                <a:cubicBezTo>
-                  <a:pt x="1303926" y="1882828"/>
-                  <a:pt x="1202115" y="351639"/>
-                  <a:pt x="1296588" y="83121"/>
-                </a:cubicBezTo>
-                <a:cubicBezTo>
-                  <a:pt x="1391061" y="-185397"/>
-                  <a:pt x="1599960" y="282629"/>
-                  <a:pt x="1743739" y="281906"/>
-                </a:cubicBezTo>
-                <a:cubicBezTo>
-                  <a:pt x="1887518" y="281183"/>
-                  <a:pt x="2032415" y="-67976"/>
-                  <a:pt x="2159260" y="78785"/>
-                </a:cubicBezTo>
-                <a:cubicBezTo>
-                  <a:pt x="2286105" y="225546"/>
-                  <a:pt x="2335381" y="993116"/>
-                  <a:pt x="2504811" y="1162471"/>
-                </a:cubicBezTo>
-                <a:cubicBezTo>
-                  <a:pt x="2674241" y="1331826"/>
-                  <a:pt x="3026985" y="1091370"/>
-                  <a:pt x="3175841" y="1094914"/>
-                </a:cubicBezTo>
-                <a:cubicBezTo>
-                  <a:pt x="3324697" y="1098458"/>
-                  <a:pt x="3372779" y="418819"/>
-                  <a:pt x="3500370" y="544638"/>
+                  <a:pt x="168348" y="127749"/>
+                  <a:pt x="432395" y="-87679"/>
+                  <a:pt x="425267" y="38411"/>
+                </a:cubicBezTo>
+                <a:cubicBezTo>
+                  <a:pt x="418139" y="164501"/>
+                  <a:pt x="541913" y="705228"/>
+                  <a:pt x="690734" y="709716"/>
+                </a:cubicBezTo>
+                <a:cubicBezTo>
+                  <a:pt x="839555" y="714204"/>
+                  <a:pt x="1142690" y="136934"/>
+                  <a:pt x="1318191" y="65340"/>
+                </a:cubicBezTo>
+                <a:cubicBezTo>
+                  <a:pt x="1493692" y="-6254"/>
+                  <a:pt x="1603561" y="278202"/>
+                  <a:pt x="1743739" y="280150"/>
+                </a:cubicBezTo>
+                <a:cubicBezTo>
+                  <a:pt x="1883917" y="282098"/>
+                  <a:pt x="2032415" y="-69732"/>
+                  <a:pt x="2159260" y="77029"/>
+                </a:cubicBezTo>
+                <a:cubicBezTo>
+                  <a:pt x="2286105" y="223790"/>
+                  <a:pt x="2335381" y="991360"/>
+                  <a:pt x="2504811" y="1160715"/>
+                </a:cubicBezTo>
+                <a:cubicBezTo>
+                  <a:pt x="2674241" y="1330070"/>
+                  <a:pt x="3026985" y="1089614"/>
+                  <a:pt x="3175841" y="1093158"/>
+                </a:cubicBezTo>
+                <a:cubicBezTo>
+                  <a:pt x="3324697" y="1096702"/>
+                  <a:pt x="3372779" y="417063"/>
+                  <a:pt x="3500370" y="542882"/>
                 </a:cubicBezTo>
               </a:path>
             </a:pathLst>
@@ -6542,10 +7999,10 @@
       </p:sp>
       <p:sp>
         <p:nvSpPr>
-          <p:cNvPr id="74" name="Freeform 73">
-            <a:extLst>
-              <a:ext uri="{FF2B5EF4-FFF2-40B4-BE49-F238E27FC236}">
-                <a16:creationId xmlns:a16="http://schemas.microsoft.com/office/drawing/2014/main" id="{4983B32B-E98C-A71F-EE99-0B584FDF714E}"/>
+          <p:cNvPr id="98" name="Oval 97">
+            <a:extLst>
+              <a:ext uri="{FF2B5EF4-FFF2-40B4-BE49-F238E27FC236}">
+                <a16:creationId xmlns:a16="http://schemas.microsoft.com/office/drawing/2014/main" id="{4642587C-EAE6-62FD-22E2-2B8028E45CC6}"/>
               </a:ext>
             </a:extLst>
           </p:cNvPr>
@@ -6553,9 +8010,360 @@
           <p:nvPr/>
         </p:nvSpPr>
         <p:spPr>
+          <a:xfrm rot="1583516">
+            <a:off x="7502241" y="4366500"/>
+            <a:ext cx="429911" cy="215649"/>
+          </a:xfrm>
+          <a:custGeom>
+            <a:avLst/>
+            <a:gdLst>
+              <a:gd name="csX0" fmla="*/ 0 w 465129"/>
+              <a:gd name="csY0" fmla="*/ 68623 h 137246"/>
+              <a:gd name="csX1" fmla="*/ 232565 w 465129"/>
+              <a:gd name="csY1" fmla="*/ 0 h 137246"/>
+              <a:gd name="csX2" fmla="*/ 465130 w 465129"/>
+              <a:gd name="csY2" fmla="*/ 68623 h 137246"/>
+              <a:gd name="csX3" fmla="*/ 232565 w 465129"/>
+              <a:gd name="csY3" fmla="*/ 137246 h 137246"/>
+              <a:gd name="csX4" fmla="*/ 0 w 465129"/>
+              <a:gd name="csY4" fmla="*/ 68623 h 137246"/>
+              <a:gd name="csX0" fmla="*/ 78 w 465208"/>
+              <a:gd name="csY0" fmla="*/ 68623 h 265532"/>
+              <a:gd name="csX1" fmla="*/ 232643 w 465208"/>
+              <a:gd name="csY1" fmla="*/ 0 h 265532"/>
+              <a:gd name="csX2" fmla="*/ 465208 w 465208"/>
+              <a:gd name="csY2" fmla="*/ 68623 h 265532"/>
+              <a:gd name="csX3" fmla="*/ 253047 w 465208"/>
+              <a:gd name="csY3" fmla="*/ 265532 h 265532"/>
+              <a:gd name="csX4" fmla="*/ 78 w 465208"/>
+              <a:gd name="csY4" fmla="*/ 68623 h 265532"/>
+              <a:gd name="csX0" fmla="*/ 59 w 451463"/>
+              <a:gd name="csY0" fmla="*/ 114669 h 266836"/>
+              <a:gd name="csX1" fmla="*/ 218898 w 451463"/>
+              <a:gd name="csY1" fmla="*/ 953 h 266836"/>
+              <a:gd name="csX2" fmla="*/ 451463 w 451463"/>
+              <a:gd name="csY2" fmla="*/ 69576 h 266836"/>
+              <a:gd name="csX3" fmla="*/ 239302 w 451463"/>
+              <a:gd name="csY3" fmla="*/ 266485 h 266836"/>
+              <a:gd name="csX4" fmla="*/ 59 w 451463"/>
+              <a:gd name="csY4" fmla="*/ 114669 h 266836"/>
+              <a:gd name="csX0" fmla="*/ 319 w 451723"/>
+              <a:gd name="csY0" fmla="*/ 54659 h 206775"/>
+              <a:gd name="csX1" fmla="*/ 194523 w 451723"/>
+              <a:gd name="csY1" fmla="*/ 65628 h 206775"/>
+              <a:gd name="csX2" fmla="*/ 451723 w 451723"/>
+              <a:gd name="csY2" fmla="*/ 9566 h 206775"/>
+              <a:gd name="csX3" fmla="*/ 239562 w 451723"/>
+              <a:gd name="csY3" fmla="*/ 206475 h 206775"/>
+              <a:gd name="csX4" fmla="*/ 319 w 451723"/>
+              <a:gd name="csY4" fmla="*/ 54659 h 206775"/>
+              <a:gd name="csX0" fmla="*/ 296 w 385572"/>
+              <a:gd name="csY0" fmla="*/ 9506 h 161930"/>
+              <a:gd name="csX1" fmla="*/ 194500 w 385572"/>
+              <a:gd name="csY1" fmla="*/ 20475 h 161930"/>
+              <a:gd name="csX2" fmla="*/ 385572 w 385572"/>
+              <a:gd name="csY2" fmla="*/ 57783 h 161930"/>
+              <a:gd name="csX3" fmla="*/ 239539 w 385572"/>
+              <a:gd name="csY3" fmla="*/ 161322 h 161930"/>
+              <a:gd name="csX4" fmla="*/ 296 w 385572"/>
+              <a:gd name="csY4" fmla="*/ 9506 h 161930"/>
+              <a:gd name="csX0" fmla="*/ 303 w 409900"/>
+              <a:gd name="csY0" fmla="*/ 8903 h 160886"/>
+              <a:gd name="csX1" fmla="*/ 194507 w 409900"/>
+              <a:gd name="csY1" fmla="*/ 19872 h 160886"/>
+              <a:gd name="csX2" fmla="*/ 409900 w 409900"/>
+              <a:gd name="csY2" fmla="*/ 36460 h 160886"/>
+              <a:gd name="csX3" fmla="*/ 239546 w 409900"/>
+              <a:gd name="csY3" fmla="*/ 160719 h 160886"/>
+              <a:gd name="csX4" fmla="*/ 303 w 409900"/>
+              <a:gd name="csY4" fmla="*/ 8903 h 160886"/>
+              <a:gd name="csX0" fmla="*/ 7 w 409604"/>
+              <a:gd name="csY0" fmla="*/ 1579 h 153562"/>
+              <a:gd name="csX1" fmla="*/ 232153 w 409604"/>
+              <a:gd name="csY1" fmla="*/ 71577 h 153562"/>
+              <a:gd name="csX2" fmla="*/ 409604 w 409604"/>
+              <a:gd name="csY2" fmla="*/ 29136 h 153562"/>
+              <a:gd name="csX3" fmla="*/ 239250 w 409604"/>
+              <a:gd name="csY3" fmla="*/ 153395 h 153562"/>
+              <a:gd name="csX4" fmla="*/ 7 w 409604"/>
+              <a:gd name="csY4" fmla="*/ 1579 h 153562"/>
+              <a:gd name="csX0" fmla="*/ 7 w 409604"/>
+              <a:gd name="csY0" fmla="*/ 1579 h 154348"/>
+              <a:gd name="csX1" fmla="*/ 232153 w 409604"/>
+              <a:gd name="csY1" fmla="*/ 71577 h 154348"/>
+              <a:gd name="csX2" fmla="*/ 409604 w 409604"/>
+              <a:gd name="csY2" fmla="*/ 29136 h 154348"/>
+              <a:gd name="csX3" fmla="*/ 239250 w 409604"/>
+              <a:gd name="csY3" fmla="*/ 153395 h 154348"/>
+              <a:gd name="csX4" fmla="*/ 7 w 409604"/>
+              <a:gd name="csY4" fmla="*/ 1579 h 154348"/>
+              <a:gd name="csX0" fmla="*/ 7 w 390635"/>
+              <a:gd name="csY0" fmla="*/ 45140 h 135237"/>
+              <a:gd name="csX1" fmla="*/ 213184 w 390635"/>
+              <a:gd name="csY1" fmla="*/ 53132 h 135237"/>
+              <a:gd name="csX2" fmla="*/ 390635 w 390635"/>
+              <a:gd name="csY2" fmla="*/ 10691 h 135237"/>
+              <a:gd name="csX3" fmla="*/ 220281 w 390635"/>
+              <a:gd name="csY3" fmla="*/ 134950 h 135237"/>
+              <a:gd name="csX4" fmla="*/ 7 w 390635"/>
+              <a:gd name="csY4" fmla="*/ 45140 h 135237"/>
+              <a:gd name="csX0" fmla="*/ 16 w 390644"/>
+              <a:gd name="csY0" fmla="*/ 45140 h 155806"/>
+              <a:gd name="csX1" fmla="*/ 213193 w 390644"/>
+              <a:gd name="csY1" fmla="*/ 53132 h 155806"/>
+              <a:gd name="csX2" fmla="*/ 390644 w 390644"/>
+              <a:gd name="csY2" fmla="*/ 10691 h 155806"/>
+              <a:gd name="csX3" fmla="*/ 202575 w 390644"/>
+              <a:gd name="csY3" fmla="*/ 155567 h 155806"/>
+              <a:gd name="csX4" fmla="*/ 16 w 390644"/>
+              <a:gd name="csY4" fmla="*/ 45140 h 155806"/>
+              <a:gd name="csX0" fmla="*/ 5 w 390633"/>
+              <a:gd name="csY0" fmla="*/ 43252 h 153910"/>
+              <a:gd name="csX1" fmla="*/ 208282 w 390633"/>
+              <a:gd name="csY1" fmla="*/ 73036 h 153910"/>
+              <a:gd name="csX2" fmla="*/ 390633 w 390633"/>
+              <a:gd name="csY2" fmla="*/ 8803 h 153910"/>
+              <a:gd name="csX3" fmla="*/ 202564 w 390633"/>
+              <a:gd name="csY3" fmla="*/ 153679 h 153910"/>
+              <a:gd name="csX4" fmla="*/ 5 w 390633"/>
+              <a:gd name="csY4" fmla="*/ 43252 h 153910"/>
+              <a:gd name="csX0" fmla="*/ 5 w 345597"/>
+              <a:gd name="csY0" fmla="*/ 7545 h 117978"/>
+              <a:gd name="csX1" fmla="*/ 208282 w 345597"/>
+              <a:gd name="csY1" fmla="*/ 37329 h 117978"/>
+              <a:gd name="csX2" fmla="*/ 345597 w 345597"/>
+              <a:gd name="csY2" fmla="*/ 12013 h 117978"/>
+              <a:gd name="csX3" fmla="*/ 202564 w 345597"/>
+              <a:gd name="csY3" fmla="*/ 117972 h 117978"/>
+              <a:gd name="csX4" fmla="*/ 5 w 345597"/>
+              <a:gd name="csY4" fmla="*/ 7545 h 117978"/>
+              <a:gd name="csX0" fmla="*/ 5 w 345597"/>
+              <a:gd name="csY0" fmla="*/ 6638 h 117071"/>
+              <a:gd name="csX1" fmla="*/ 208282 w 345597"/>
+              <a:gd name="csY1" fmla="*/ 36422 h 117071"/>
+              <a:gd name="csX2" fmla="*/ 345597 w 345597"/>
+              <a:gd name="csY2" fmla="*/ 11106 h 117071"/>
+              <a:gd name="csX3" fmla="*/ 202564 w 345597"/>
+              <a:gd name="csY3" fmla="*/ 117065 h 117071"/>
+              <a:gd name="csX4" fmla="*/ 5 w 345597"/>
+              <a:gd name="csY4" fmla="*/ 6638 h 117071"/>
+              <a:gd name="csX0" fmla="*/ 5 w 351513"/>
+              <a:gd name="csY0" fmla="*/ 11463 h 121894"/>
+              <a:gd name="csX1" fmla="*/ 345597 w 351513"/>
+              <a:gd name="csY1" fmla="*/ 15931 h 121894"/>
+              <a:gd name="csX2" fmla="*/ 202564 w 351513"/>
+              <a:gd name="csY2" fmla="*/ 121890 h 121894"/>
+              <a:gd name="csX3" fmla="*/ 5 w 351513"/>
+              <a:gd name="csY3" fmla="*/ 11463 h 121894"/>
+              <a:gd name="csX0" fmla="*/ 5 w 351513"/>
+              <a:gd name="csY0" fmla="*/ 2330 h 112761"/>
+              <a:gd name="csX1" fmla="*/ 345597 w 351513"/>
+              <a:gd name="csY1" fmla="*/ 6798 h 112761"/>
+              <a:gd name="csX2" fmla="*/ 202564 w 351513"/>
+              <a:gd name="csY2" fmla="*/ 112757 h 112761"/>
+              <a:gd name="csX3" fmla="*/ 5 w 351513"/>
+              <a:gd name="csY3" fmla="*/ 2330 h 112761"/>
+              <a:gd name="csX0" fmla="*/ 2228 w 353799"/>
+              <a:gd name="csY0" fmla="*/ 2871 h 127075"/>
+              <a:gd name="csX1" fmla="*/ 347820 w 353799"/>
+              <a:gd name="csY1" fmla="*/ 7339 h 127075"/>
+              <a:gd name="csX2" fmla="*/ 206331 w 353799"/>
+              <a:gd name="csY2" fmla="*/ 127071 h 127075"/>
+              <a:gd name="csX3" fmla="*/ 2228 w 353799"/>
+              <a:gd name="csY3" fmla="*/ 2871 h 127075"/>
+            </a:gdLst>
+            <a:ahLst/>
+            <a:cxnLst>
+              <a:cxn ang="0">
+                <a:pos x="csX0" y="csY0"/>
+              </a:cxn>
+              <a:cxn ang="0">
+                <a:pos x="csX1" y="csY1"/>
+              </a:cxn>
+              <a:cxn ang="0">
+                <a:pos x="csX2" y="csY2"/>
+              </a:cxn>
+              <a:cxn ang="0">
+                <a:pos x="csX3" y="csY3"/>
+              </a:cxn>
+            </a:cxnLst>
+            <a:rect l="l" t="t" r="r" b="b"/>
+            <a:pathLst>
+              <a:path w="353799" h="127075">
+                <a:moveTo>
+                  <a:pt x="2228" y="2871"/>
+                </a:moveTo>
+                <a:cubicBezTo>
+                  <a:pt x="25810" y="-17084"/>
+                  <a:pt x="230359" y="75962"/>
+                  <a:pt x="347820" y="7339"/>
+                </a:cubicBezTo>
+                <a:cubicBezTo>
+                  <a:pt x="381580" y="25744"/>
+                  <a:pt x="263930" y="127816"/>
+                  <a:pt x="206331" y="127071"/>
+                </a:cubicBezTo>
+                <a:cubicBezTo>
+                  <a:pt x="148732" y="126326"/>
+                  <a:pt x="-21354" y="22826"/>
+                  <a:pt x="2228" y="2871"/>
+                </a:cubicBezTo>
+                <a:close/>
+              </a:path>
+            </a:pathLst>
+          </a:custGeom>
+          <a:pattFill prst="lgConfetti">
+            <a:fgClr>
+              <a:srgbClr val="FFC000"/>
+            </a:fgClr>
+            <a:bgClr>
+              <a:schemeClr val="bg1"/>
+            </a:bgClr>
+          </a:pattFill>
+          <a:ln>
+            <a:solidFill>
+              <a:srgbClr val="5B280D"/>
+            </a:solidFill>
+            <a:extLst>
+              <a:ext uri="{C807C97D-BFC1-408E-A445-0C87EB9F89A2}">
+                <ask:lineSketchStyleProps xmlns:ask="http://schemas.microsoft.com/office/drawing/2018/sketchyshapes" sd="1219033472">
+                  <a:custGeom>
+                    <a:avLst/>
+                    <a:gdLst>
+                      <a:gd name="csX0" fmla="*/ 8 w 497720"/>
+                      <a:gd name="csY0" fmla="*/ 2679 h 261931"/>
+                      <a:gd name="csX1" fmla="*/ 282094 w 497720"/>
+                      <a:gd name="csY1" fmla="*/ 121467 h 261931"/>
+                      <a:gd name="csX2" fmla="*/ 497720 w 497720"/>
+                      <a:gd name="csY2" fmla="*/ 49444 h 261931"/>
+                      <a:gd name="csX3" fmla="*/ 290718 w 497720"/>
+                      <a:gd name="csY3" fmla="*/ 260313 h 261931"/>
+                      <a:gd name="csX4" fmla="*/ 8 w 497720"/>
+                      <a:gd name="csY4" fmla="*/ 2679 h 261931"/>
+                    </a:gdLst>
+                    <a:ahLst/>
+                    <a:cxnLst>
+                      <a:cxn ang="0">
+                        <a:pos x="csX0" y="csY0"/>
+                      </a:cxn>
+                      <a:cxn ang="0">
+                        <a:pos x="csX1" y="csY1"/>
+                      </a:cxn>
+                      <a:cxn ang="0">
+                        <a:pos x="csX2" y="csY2"/>
+                      </a:cxn>
+                      <a:cxn ang="0">
+                        <a:pos x="csX3" y="csY3"/>
+                      </a:cxn>
+                      <a:cxn ang="0">
+                        <a:pos x="csX4" y="csY4"/>
+                      </a:cxn>
+                    </a:cxnLst>
+                    <a:rect l="l" t="t" r="r" b="b"/>
+                    <a:pathLst>
+                      <a:path w="497720" h="261931" fill="none" extrusionOk="0">
+                        <a:moveTo>
+                          <a:pt x="8" y="2679"/>
+                        </a:moveTo>
+                        <a:cubicBezTo>
+                          <a:pt x="5795" y="-19604"/>
+                          <a:pt x="205988" y="99586"/>
+                          <a:pt x="282094" y="121467"/>
+                        </a:cubicBezTo>
+                        <a:cubicBezTo>
+                          <a:pt x="356247" y="127914"/>
+                          <a:pt x="488116" y="-5829"/>
+                          <a:pt x="497720" y="49444"/>
+                        </a:cubicBezTo>
+                        <a:cubicBezTo>
+                          <a:pt x="497251" y="109283"/>
+                          <a:pt x="401702" y="305449"/>
+                          <a:pt x="290718" y="260313"/>
+                        </a:cubicBezTo>
+                        <a:cubicBezTo>
+                          <a:pt x="165143" y="242616"/>
+                          <a:pt x="2999" y="26194"/>
+                          <a:pt x="8" y="2679"/>
+                        </a:cubicBezTo>
+                        <a:close/>
+                      </a:path>
+                      <a:path w="497720" h="261931" stroke="0" extrusionOk="0">
+                        <a:moveTo>
+                          <a:pt x="8" y="2679"/>
+                        </a:moveTo>
+                        <a:cubicBezTo>
+                          <a:pt x="-5842" y="-23183"/>
+                          <a:pt x="191163" y="116667"/>
+                          <a:pt x="282094" y="121467"/>
+                        </a:cubicBezTo>
+                        <a:cubicBezTo>
+                          <a:pt x="380168" y="132444"/>
+                          <a:pt x="493334" y="-14732"/>
+                          <a:pt x="497720" y="49444"/>
+                        </a:cubicBezTo>
+                        <a:cubicBezTo>
+                          <a:pt x="490852" y="120466"/>
+                          <a:pt x="416270" y="300497"/>
+                          <a:pt x="290718" y="260313"/>
+                        </a:cubicBezTo>
+                        <a:cubicBezTo>
+                          <a:pt x="156436" y="237806"/>
+                          <a:pt x="2814" y="26474"/>
+                          <a:pt x="8" y="2679"/>
+                        </a:cubicBezTo>
+                        <a:close/>
+                      </a:path>
+                    </a:pathLst>
+                  </a:custGeom>
+                  <ask:type>
+                    <ask:lineSketchNone/>
+                  </ask:type>
+                </ask:lineSketchStyleProps>
+              </a:ext>
+            </a:extLst>
+          </a:ln>
+        </p:spPr>
+        <p:style>
+          <a:lnRef idx="2">
+            <a:schemeClr val="accent1">
+              <a:shade val="15000"/>
+            </a:schemeClr>
+          </a:lnRef>
+          <a:fillRef idx="1">
+            <a:schemeClr val="accent1"/>
+          </a:fillRef>
+          <a:effectRef idx="0">
+            <a:schemeClr val="accent1"/>
+          </a:effectRef>
+          <a:fontRef idx="minor">
+            <a:schemeClr val="lt1"/>
+          </a:fontRef>
+        </p:style>
+        <p:txBody>
+          <a:bodyPr rtlCol="0" anchor="ctr"/>
+          <a:lstStyle/>
+          <a:p>
+            <a:pPr algn="ctr"/>
+            <a:endParaRPr lang="en-US"/>
+          </a:p>
+        </p:txBody>
+      </p:sp>
+      <p:sp>
+        <p:nvSpPr>
+          <p:cNvPr id="103" name="Freeform 102">
+            <a:extLst>
+              <a:ext uri="{FF2B5EF4-FFF2-40B4-BE49-F238E27FC236}">
+                <a16:creationId xmlns:a16="http://schemas.microsoft.com/office/drawing/2014/main" id="{F29898CA-EEDD-9A8B-33EF-33BBCED76420}"/>
+              </a:ext>
+            </a:extLst>
+          </p:cNvPr>
+          <p:cNvSpPr/>
+          <p:nvPr/>
+        </p:nvSpPr>
+        <p:spPr>
           <a:xfrm rot="583769">
-            <a:off x="7077758" y="967516"/>
-            <a:ext cx="3455583" cy="230455"/>
+            <a:off x="7064720" y="5261997"/>
+            <a:ext cx="1743741" cy="112828"/>
           </a:xfrm>
           <a:custGeom>
             <a:avLst/>
@@ -6578,6 +8386,58 @@
               <a:gd name="csY7" fmla="*/ 64121 h 319302"/>
               <a:gd name="csX8" fmla="*/ 3455582 w 3455582"/>
               <a:gd name="csY8" fmla="*/ 319302 h 319302"/>
+              <a:gd name="csX0" fmla="*/ 0 w 3051544"/>
+              <a:gd name="csY0" fmla="*/ 212977 h 298123"/>
+              <a:gd name="csX1" fmla="*/ 499730 w 3051544"/>
+              <a:gd name="csY1" fmla="*/ 325 h 298123"/>
+              <a:gd name="csX2" fmla="*/ 978196 w 3051544"/>
+              <a:gd name="csY2" fmla="*/ 255507 h 298123"/>
+              <a:gd name="csX3" fmla="*/ 1371600 w 3051544"/>
+              <a:gd name="csY3" fmla="*/ 10958 h 298123"/>
+              <a:gd name="csX4" fmla="*/ 1743740 w 3051544"/>
+              <a:gd name="csY4" fmla="*/ 255507 h 298123"/>
+              <a:gd name="csX5" fmla="*/ 2126512 w 3051544"/>
+              <a:gd name="csY5" fmla="*/ 32223 h 298123"/>
+              <a:gd name="csX6" fmla="*/ 2562447 w 3051544"/>
+              <a:gd name="csY6" fmla="*/ 298037 h 298123"/>
+              <a:gd name="csX7" fmla="*/ 3051544 w 3051544"/>
+              <a:gd name="csY7" fmla="*/ 64121 h 298123"/>
+              <a:gd name="csX0" fmla="*/ 0 w 2562447"/>
+              <a:gd name="csY0" fmla="*/ 212977 h 298037"/>
+              <a:gd name="csX1" fmla="*/ 499730 w 2562447"/>
+              <a:gd name="csY1" fmla="*/ 325 h 298037"/>
+              <a:gd name="csX2" fmla="*/ 978196 w 2562447"/>
+              <a:gd name="csY2" fmla="*/ 255507 h 298037"/>
+              <a:gd name="csX3" fmla="*/ 1371600 w 2562447"/>
+              <a:gd name="csY3" fmla="*/ 10958 h 298037"/>
+              <a:gd name="csX4" fmla="*/ 1743740 w 2562447"/>
+              <a:gd name="csY4" fmla="*/ 255507 h 298037"/>
+              <a:gd name="csX5" fmla="*/ 2126512 w 2562447"/>
+              <a:gd name="csY5" fmla="*/ 32223 h 298037"/>
+              <a:gd name="csX6" fmla="*/ 2562447 w 2562447"/>
+              <a:gd name="csY6" fmla="*/ 298037 h 298037"/>
+              <a:gd name="csX0" fmla="*/ 0 w 2126512"/>
+              <a:gd name="csY0" fmla="*/ 212977 h 255545"/>
+              <a:gd name="csX1" fmla="*/ 499730 w 2126512"/>
+              <a:gd name="csY1" fmla="*/ 325 h 255545"/>
+              <a:gd name="csX2" fmla="*/ 978196 w 2126512"/>
+              <a:gd name="csY2" fmla="*/ 255507 h 255545"/>
+              <a:gd name="csX3" fmla="*/ 1371600 w 2126512"/>
+              <a:gd name="csY3" fmla="*/ 10958 h 255545"/>
+              <a:gd name="csX4" fmla="*/ 1743740 w 2126512"/>
+              <a:gd name="csY4" fmla="*/ 255507 h 255545"/>
+              <a:gd name="csX5" fmla="*/ 2126512 w 2126512"/>
+              <a:gd name="csY5" fmla="*/ 32223 h 255545"/>
+              <a:gd name="csX0" fmla="*/ 0 w 1743740"/>
+              <a:gd name="csY0" fmla="*/ 212977 h 255516"/>
+              <a:gd name="csX1" fmla="*/ 499730 w 1743740"/>
+              <a:gd name="csY1" fmla="*/ 325 h 255516"/>
+              <a:gd name="csX2" fmla="*/ 978196 w 1743740"/>
+              <a:gd name="csY2" fmla="*/ 255507 h 255516"/>
+              <a:gd name="csX3" fmla="*/ 1371600 w 1743740"/>
+              <a:gd name="csY3" fmla="*/ 10958 h 255516"/>
+              <a:gd name="csX4" fmla="*/ 1743740 w 1743740"/>
+              <a:gd name="csY4" fmla="*/ 255507 h 255516"/>
             </a:gdLst>
             <a:ahLst/>
             <a:cxnLst>
@@ -6596,22 +8456,10 @@
               <a:cxn ang="0">
                 <a:pos x="csX4" y="csY4"/>
               </a:cxn>
-              <a:cxn ang="0">
-                <a:pos x="csX5" y="csY5"/>
-              </a:cxn>
-              <a:cxn ang="0">
-                <a:pos x="csX6" y="csY6"/>
-              </a:cxn>
-              <a:cxn ang="0">
-                <a:pos x="csX7" y="csY7"/>
-              </a:cxn>
-              <a:cxn ang="0">
-                <a:pos x="csX8" y="csY8"/>
-              </a:cxn>
             </a:cxnLst>
             <a:rect l="l" t="t" r="r" b="b"/>
             <a:pathLst>
-              <a:path w="3455582" h="319302">
+              <a:path w="1743740" h="255516">
                 <a:moveTo>
                   <a:pt x="0" y="212977"/>
                 </a:moveTo>
@@ -6634,215 +8482,6 @@
                   <a:pt x="1499191" y="10958"/>
                   <a:pt x="1617921" y="251963"/>
                   <a:pt x="1743740" y="255507"/>
-                </a:cubicBezTo>
-                <a:cubicBezTo>
-                  <a:pt x="1869559" y="259051"/>
-                  <a:pt x="1990061" y="25135"/>
-                  <a:pt x="2126512" y="32223"/>
-                </a:cubicBezTo>
-                <a:cubicBezTo>
-                  <a:pt x="2262963" y="39311"/>
-                  <a:pt x="2408275" y="292721"/>
-                  <a:pt x="2562447" y="298037"/>
-                </a:cubicBezTo>
-                <a:cubicBezTo>
-                  <a:pt x="2716619" y="303353"/>
-                  <a:pt x="2902688" y="60577"/>
-                  <a:pt x="3051544" y="64121"/>
-                </a:cubicBezTo>
-                <a:cubicBezTo>
-                  <a:pt x="3200400" y="67665"/>
-                  <a:pt x="3327991" y="193483"/>
-                  <a:pt x="3455582" y="319302"/>
-                </a:cubicBezTo>
-              </a:path>
-            </a:pathLst>
-          </a:custGeom>
-          <a:noFill/>
-          <a:ln w="28575">
-            <a:solidFill>
-              <a:schemeClr val="accent6">
-                <a:lumMod val="75000"/>
-              </a:schemeClr>
-            </a:solidFill>
-            <a:prstDash val="sysDot"/>
-          </a:ln>
-        </p:spPr>
-        <p:style>
-          <a:lnRef idx="2">
-            <a:schemeClr val="accent1">
-              <a:shade val="15000"/>
-            </a:schemeClr>
-          </a:lnRef>
-          <a:fillRef idx="1">
-            <a:schemeClr val="accent1"/>
-          </a:fillRef>
-          <a:effectRef idx="0">
-            <a:schemeClr val="accent1"/>
-          </a:effectRef>
-          <a:fontRef idx="minor">
-            <a:schemeClr val="lt1"/>
-          </a:fontRef>
-        </p:style>
-        <p:txBody>
-          <a:bodyPr rtlCol="0" anchor="ctr"/>
-          <a:lstStyle/>
-          <a:p>
-            <a:pPr algn="ctr"/>
-            <a:endParaRPr lang="en-US"/>
-          </a:p>
-        </p:txBody>
-      </p:sp>
-      <p:sp>
-        <p:nvSpPr>
-          <p:cNvPr id="76" name="Freeform 75">
-            <a:extLst>
-              <a:ext uri="{FF2B5EF4-FFF2-40B4-BE49-F238E27FC236}">
-                <a16:creationId xmlns:a16="http://schemas.microsoft.com/office/drawing/2014/main" id="{2D9F42F4-5E81-E7D1-3F93-E8F0302E8840}"/>
-              </a:ext>
-            </a:extLst>
-          </p:cNvPr>
-          <p:cNvSpPr/>
-          <p:nvPr/>
-        </p:nvSpPr>
-        <p:spPr>
-          <a:xfrm rot="583769">
-            <a:off x="7091785" y="5192494"/>
-            <a:ext cx="834137" cy="96281"/>
-          </a:xfrm>
-          <a:custGeom>
-            <a:avLst/>
-            <a:gdLst>
-              <a:gd name="csX0" fmla="*/ 0 w 3455582"/>
-              <a:gd name="csY0" fmla="*/ 212977 h 319302"/>
-              <a:gd name="csX1" fmla="*/ 499730 w 3455582"/>
-              <a:gd name="csY1" fmla="*/ 325 h 319302"/>
-              <a:gd name="csX2" fmla="*/ 978196 w 3455582"/>
-              <a:gd name="csY2" fmla="*/ 255507 h 319302"/>
-              <a:gd name="csX3" fmla="*/ 1371600 w 3455582"/>
-              <a:gd name="csY3" fmla="*/ 10958 h 319302"/>
-              <a:gd name="csX4" fmla="*/ 1743740 w 3455582"/>
-              <a:gd name="csY4" fmla="*/ 255507 h 319302"/>
-              <a:gd name="csX5" fmla="*/ 2126512 w 3455582"/>
-              <a:gd name="csY5" fmla="*/ 32223 h 319302"/>
-              <a:gd name="csX6" fmla="*/ 2562447 w 3455582"/>
-              <a:gd name="csY6" fmla="*/ 298037 h 319302"/>
-              <a:gd name="csX7" fmla="*/ 3051544 w 3455582"/>
-              <a:gd name="csY7" fmla="*/ 64121 h 319302"/>
-              <a:gd name="csX8" fmla="*/ 3455582 w 3455582"/>
-              <a:gd name="csY8" fmla="*/ 319302 h 319302"/>
-              <a:gd name="csX0" fmla="*/ 0 w 3455582"/>
-              <a:gd name="csY0" fmla="*/ 218043 h 324368"/>
-              <a:gd name="csX1" fmla="*/ 499730 w 3455582"/>
-              <a:gd name="csY1" fmla="*/ 5391 h 324368"/>
-              <a:gd name="csX2" fmla="*/ 834136 w 3455582"/>
-              <a:gd name="csY2" fmla="*/ 59721 h 324368"/>
-              <a:gd name="csX3" fmla="*/ 1371600 w 3455582"/>
-              <a:gd name="csY3" fmla="*/ 16024 h 324368"/>
-              <a:gd name="csX4" fmla="*/ 1743740 w 3455582"/>
-              <a:gd name="csY4" fmla="*/ 260573 h 324368"/>
-              <a:gd name="csX5" fmla="*/ 2126512 w 3455582"/>
-              <a:gd name="csY5" fmla="*/ 37289 h 324368"/>
-              <a:gd name="csX6" fmla="*/ 2562447 w 3455582"/>
-              <a:gd name="csY6" fmla="*/ 303103 h 324368"/>
-              <a:gd name="csX7" fmla="*/ 3051544 w 3455582"/>
-              <a:gd name="csY7" fmla="*/ 69187 h 324368"/>
-              <a:gd name="csX8" fmla="*/ 3455582 w 3455582"/>
-              <a:gd name="csY8" fmla="*/ 324368 h 324368"/>
-              <a:gd name="csX0" fmla="*/ 0 w 3051544"/>
-              <a:gd name="csY0" fmla="*/ 218043 h 303189"/>
-              <a:gd name="csX1" fmla="*/ 499730 w 3051544"/>
-              <a:gd name="csY1" fmla="*/ 5391 h 303189"/>
-              <a:gd name="csX2" fmla="*/ 834136 w 3051544"/>
-              <a:gd name="csY2" fmla="*/ 59721 h 303189"/>
-              <a:gd name="csX3" fmla="*/ 1371600 w 3051544"/>
-              <a:gd name="csY3" fmla="*/ 16024 h 303189"/>
-              <a:gd name="csX4" fmla="*/ 1743740 w 3051544"/>
-              <a:gd name="csY4" fmla="*/ 260573 h 303189"/>
-              <a:gd name="csX5" fmla="*/ 2126512 w 3051544"/>
-              <a:gd name="csY5" fmla="*/ 37289 h 303189"/>
-              <a:gd name="csX6" fmla="*/ 2562447 w 3051544"/>
-              <a:gd name="csY6" fmla="*/ 303103 h 303189"/>
-              <a:gd name="csX7" fmla="*/ 3051544 w 3051544"/>
-              <a:gd name="csY7" fmla="*/ 69187 h 303189"/>
-              <a:gd name="csX0" fmla="*/ 0 w 2562447"/>
-              <a:gd name="csY0" fmla="*/ 218043 h 303103"/>
-              <a:gd name="csX1" fmla="*/ 499730 w 2562447"/>
-              <a:gd name="csY1" fmla="*/ 5391 h 303103"/>
-              <a:gd name="csX2" fmla="*/ 834136 w 2562447"/>
-              <a:gd name="csY2" fmla="*/ 59721 h 303103"/>
-              <a:gd name="csX3" fmla="*/ 1371600 w 2562447"/>
-              <a:gd name="csY3" fmla="*/ 16024 h 303103"/>
-              <a:gd name="csX4" fmla="*/ 1743740 w 2562447"/>
-              <a:gd name="csY4" fmla="*/ 260573 h 303103"/>
-              <a:gd name="csX5" fmla="*/ 2126512 w 2562447"/>
-              <a:gd name="csY5" fmla="*/ 37289 h 303103"/>
-              <a:gd name="csX6" fmla="*/ 2562447 w 2562447"/>
-              <a:gd name="csY6" fmla="*/ 303103 h 303103"/>
-              <a:gd name="csX0" fmla="*/ 0 w 2126512"/>
-              <a:gd name="csY0" fmla="*/ 218043 h 260611"/>
-              <a:gd name="csX1" fmla="*/ 499730 w 2126512"/>
-              <a:gd name="csY1" fmla="*/ 5391 h 260611"/>
-              <a:gd name="csX2" fmla="*/ 834136 w 2126512"/>
-              <a:gd name="csY2" fmla="*/ 59721 h 260611"/>
-              <a:gd name="csX3" fmla="*/ 1371600 w 2126512"/>
-              <a:gd name="csY3" fmla="*/ 16024 h 260611"/>
-              <a:gd name="csX4" fmla="*/ 1743740 w 2126512"/>
-              <a:gd name="csY4" fmla="*/ 260573 h 260611"/>
-              <a:gd name="csX5" fmla="*/ 2126512 w 2126512"/>
-              <a:gd name="csY5" fmla="*/ 37289 h 260611"/>
-              <a:gd name="csX0" fmla="*/ 0 w 1743740"/>
-              <a:gd name="csY0" fmla="*/ 218043 h 260573"/>
-              <a:gd name="csX1" fmla="*/ 499730 w 1743740"/>
-              <a:gd name="csY1" fmla="*/ 5391 h 260573"/>
-              <a:gd name="csX2" fmla="*/ 834136 w 1743740"/>
-              <a:gd name="csY2" fmla="*/ 59721 h 260573"/>
-              <a:gd name="csX3" fmla="*/ 1371600 w 1743740"/>
-              <a:gd name="csY3" fmla="*/ 16024 h 260573"/>
-              <a:gd name="csX4" fmla="*/ 1743740 w 1743740"/>
-              <a:gd name="csY4" fmla="*/ 260573 h 260573"/>
-              <a:gd name="csX0" fmla="*/ 0 w 1371600"/>
-              <a:gd name="csY0" fmla="*/ 218043 h 218043"/>
-              <a:gd name="csX1" fmla="*/ 499730 w 1371600"/>
-              <a:gd name="csY1" fmla="*/ 5391 h 218043"/>
-              <a:gd name="csX2" fmla="*/ 834136 w 1371600"/>
-              <a:gd name="csY2" fmla="*/ 59721 h 218043"/>
-              <a:gd name="csX3" fmla="*/ 1371600 w 1371600"/>
-              <a:gd name="csY3" fmla="*/ 16024 h 218043"/>
-              <a:gd name="csX0" fmla="*/ 0 w 834136"/>
-              <a:gd name="csY0" fmla="*/ 218043 h 218043"/>
-              <a:gd name="csX1" fmla="*/ 499730 w 834136"/>
-              <a:gd name="csY1" fmla="*/ 5391 h 218043"/>
-              <a:gd name="csX2" fmla="*/ 834136 w 834136"/>
-              <a:gd name="csY2" fmla="*/ 59721 h 218043"/>
-            </a:gdLst>
-            <a:ahLst/>
-            <a:cxnLst>
-              <a:cxn ang="0">
-                <a:pos x="csX0" y="csY0"/>
-              </a:cxn>
-              <a:cxn ang="0">
-                <a:pos x="csX1" y="csY1"/>
-              </a:cxn>
-              <a:cxn ang="0">
-                <a:pos x="csX2" y="csY2"/>
-              </a:cxn>
-            </a:cxnLst>
-            <a:rect l="l" t="t" r="r" b="b"/>
-            <a:pathLst>
-              <a:path w="834136" h="218043">
-                <a:moveTo>
-                  <a:pt x="0" y="218043"/>
-                </a:moveTo>
-                <a:cubicBezTo>
-                  <a:pt x="168348" y="108173"/>
-                  <a:pt x="360707" y="31778"/>
-                  <a:pt x="499730" y="5391"/>
-                </a:cubicBezTo>
-                <a:cubicBezTo>
-                  <a:pt x="638753" y="-20996"/>
-                  <a:pt x="688824" y="57949"/>
-                  <a:pt x="834136" y="59721"/>
                 </a:cubicBezTo>
               </a:path>
             </a:pathLst>
@@ -6880,962 +8519,324 @@
           </a:p>
         </p:txBody>
       </p:sp>
-      <p:sp>
-        <p:nvSpPr>
-          <p:cNvPr id="78" name="Oval 77">
-            <a:extLst>
-              <a:ext uri="{FF2B5EF4-FFF2-40B4-BE49-F238E27FC236}">
-                <a16:creationId xmlns:a16="http://schemas.microsoft.com/office/drawing/2014/main" id="{F1350447-D59A-ACC6-B92E-8B1BD2CB5374}"/>
-              </a:ext>
-            </a:extLst>
-          </p:cNvPr>
-          <p:cNvSpPr/>
+      <p:cxnSp>
+        <p:nvCxnSpPr>
+          <p:cNvPr id="104" name="Straight Arrow Connector 103">
+            <a:extLst>
+              <a:ext uri="{FF2B5EF4-FFF2-40B4-BE49-F238E27FC236}">
+                <a16:creationId xmlns:a16="http://schemas.microsoft.com/office/drawing/2014/main" id="{A401C3F1-F482-75A7-6747-C0A722C91C36}"/>
+              </a:ext>
+            </a:extLst>
+          </p:cNvPr>
+          <p:cNvCxnSpPr>
+            <a:cxnSpLocks/>
+          </p:cNvCxnSpPr>
           <p:nvPr/>
-        </p:nvSpPr>
+        </p:nvCxnSpPr>
         <p:spPr>
           <a:xfrm>
-            <a:off x="7156233" y="5298863"/>
-            <a:ext cx="776906" cy="124548"/>
+            <a:off x="8794368" y="5056712"/>
+            <a:ext cx="0" cy="436493"/>
           </a:xfrm>
-          <a:custGeom>
+          <a:prstGeom prst="straightConnector1">
             <a:avLst/>
-            <a:gdLst>
-              <a:gd name="csX0" fmla="*/ 205 w 776906"/>
-              <a:gd name="csY0" fmla="*/ 62274 h 124548"/>
-              <a:gd name="csX1" fmla="*/ 659514 w 776906"/>
-              <a:gd name="csY1" fmla="*/ 0 h 124548"/>
-              <a:gd name="csX2" fmla="*/ 776591 w 776906"/>
-              <a:gd name="csY2" fmla="*/ 62274 h 124548"/>
-              <a:gd name="csX3" fmla="*/ 590503 w 776906"/>
-              <a:gd name="csY3" fmla="*/ 124548 h 124548"/>
-              <a:gd name="csX4" fmla="*/ 205 w 776906"/>
-              <a:gd name="csY4" fmla="*/ 62274 h 124548"/>
-            </a:gdLst>
-            <a:ahLst/>
-            <a:cxnLst>
-              <a:cxn ang="0">
-                <a:pos x="csX0" y="csY0"/>
-              </a:cxn>
-              <a:cxn ang="0">
-                <a:pos x="csX1" y="csY1"/>
-              </a:cxn>
-              <a:cxn ang="0">
-                <a:pos x="csX2" y="csY2"/>
-              </a:cxn>
-              <a:cxn ang="0">
-                <a:pos x="csX3" y="csY3"/>
-              </a:cxn>
-              <a:cxn ang="0">
-                <a:pos x="csX4" y="csY4"/>
-              </a:cxn>
-            </a:cxnLst>
-            <a:rect l="l" t="t" r="r" b="b"/>
-            <a:pathLst>
-              <a:path w="776906" h="124548" fill="none" extrusionOk="0">
-                <a:moveTo>
-                  <a:pt x="205" y="62274"/>
-                </a:moveTo>
-                <a:cubicBezTo>
-                  <a:pt x="40828" y="44971"/>
-                  <a:pt x="534156" y="-8312"/>
-                  <a:pt x="659514" y="0"/>
-                </a:cubicBezTo>
-                <a:cubicBezTo>
-                  <a:pt x="786842" y="-317"/>
-                  <a:pt x="772940" y="31318"/>
-                  <a:pt x="776591" y="62274"/>
-                </a:cubicBezTo>
-                <a:cubicBezTo>
-                  <a:pt x="774939" y="80914"/>
-                  <a:pt x="714274" y="132367"/>
-                  <a:pt x="590503" y="124548"/>
-                </a:cubicBezTo>
-                <a:cubicBezTo>
-                  <a:pt x="462839" y="125518"/>
-                  <a:pt x="-4790" y="84596"/>
-                  <a:pt x="205" y="62274"/>
-                </a:cubicBezTo>
-                <a:close/>
-              </a:path>
-              <a:path w="776906" h="124548" stroke="0" extrusionOk="0">
-                <a:moveTo>
-                  <a:pt x="205" y="62274"/>
-                </a:moveTo>
-                <a:cubicBezTo>
-                  <a:pt x="-15563" y="24695"/>
-                  <a:pt x="498853" y="11734"/>
-                  <a:pt x="659514" y="0"/>
-                </a:cubicBezTo>
-                <a:cubicBezTo>
-                  <a:pt x="793780" y="1025"/>
-                  <a:pt x="769511" y="28106"/>
-                  <a:pt x="776591" y="62274"/>
-                </a:cubicBezTo>
-                <a:cubicBezTo>
-                  <a:pt x="768200" y="104862"/>
-                  <a:pt x="718611" y="131672"/>
-                  <a:pt x="590503" y="124548"/>
-                </a:cubicBezTo>
-                <a:cubicBezTo>
-                  <a:pt x="457072" y="122341"/>
-                  <a:pt x="-6210" y="85462"/>
-                  <a:pt x="205" y="62274"/>
-                </a:cubicBezTo>
-                <a:close/>
-              </a:path>
-            </a:pathLst>
-          </a:custGeom>
-          <a:pattFill prst="dkUpDiag">
-            <a:fgClr>
-              <a:schemeClr val="accent1">
-                <a:lumMod val="20000"/>
-                <a:lumOff val="80000"/>
-              </a:schemeClr>
-            </a:fgClr>
-            <a:bgClr>
-              <a:schemeClr val="bg1"/>
-            </a:bgClr>
-          </a:pattFill>
+          </a:prstGeom>
           <a:ln>
             <a:solidFill>
-              <a:schemeClr val="accent1">
-                <a:lumMod val="60000"/>
-                <a:lumOff val="40000"/>
-              </a:schemeClr>
+              <a:srgbClr val="C00000"/>
             </a:solidFill>
-            <a:extLst>
-              <a:ext uri="{C807C97D-BFC1-408E-A445-0C87EB9F89A2}">
-                <ask:lineSketchStyleProps xmlns:ask="http://schemas.microsoft.com/office/drawing/2018/sketchyshapes" sd="1219033472">
-                  <a:custGeom>
-                    <a:avLst/>
-                    <a:gdLst>
-                      <a:gd name="csX0" fmla="*/ 0 w 1216668"/>
-                      <a:gd name="csY0" fmla="*/ 62274 h 124547"/>
-                      <a:gd name="csX1" fmla="*/ 608334 w 1216668"/>
-                      <a:gd name="csY1" fmla="*/ 0 h 124547"/>
-                      <a:gd name="csX2" fmla="*/ 1216668 w 1216668"/>
-                      <a:gd name="csY2" fmla="*/ 62274 h 124547"/>
-                      <a:gd name="csX3" fmla="*/ 608334 w 1216668"/>
-                      <a:gd name="csY3" fmla="*/ 124548 h 124547"/>
-                      <a:gd name="csX4" fmla="*/ 0 w 1216668"/>
-                      <a:gd name="csY4" fmla="*/ 62274 h 124547"/>
-                      <a:gd name="csX0" fmla="*/ 0 w 800108"/>
-                      <a:gd name="csY0" fmla="*/ 62274 h 124548"/>
-                      <a:gd name="csX1" fmla="*/ 608334 w 800108"/>
-                      <a:gd name="csY1" fmla="*/ 0 h 124548"/>
-                      <a:gd name="csX2" fmla="*/ 800108 w 800108"/>
-                      <a:gd name="csY2" fmla="*/ 62274 h 124548"/>
-                      <a:gd name="csX3" fmla="*/ 608334 w 800108"/>
-                      <a:gd name="csY3" fmla="*/ 124548 h 124548"/>
-                      <a:gd name="csX4" fmla="*/ 0 w 800108"/>
-                      <a:gd name="csY4" fmla="*/ 62274 h 124548"/>
-                      <a:gd name="csX0" fmla="*/ 212 w 800644"/>
-                      <a:gd name="csY0" fmla="*/ 62274 h 124548"/>
-                      <a:gd name="csX1" fmla="*/ 679666 w 800644"/>
-                      <a:gd name="csY1" fmla="*/ 0 h 124548"/>
-                      <a:gd name="csX2" fmla="*/ 800320 w 800644"/>
-                      <a:gd name="csY2" fmla="*/ 62274 h 124548"/>
-                      <a:gd name="csX3" fmla="*/ 608546 w 800644"/>
-                      <a:gd name="csY3" fmla="*/ 124548 h 124548"/>
-                      <a:gd name="csX4" fmla="*/ 212 w 800644"/>
-                      <a:gd name="csY4" fmla="*/ 62274 h 124548"/>
-                    </a:gdLst>
-                    <a:ahLst/>
-                    <a:cxnLst>
-                      <a:cxn ang="0">
-                        <a:pos x="csX0" y="csY0"/>
-                      </a:cxn>
-                      <a:cxn ang="0">
-                        <a:pos x="csX1" y="csY1"/>
-                      </a:cxn>
-                      <a:cxn ang="0">
-                        <a:pos x="csX2" y="csY2"/>
-                      </a:cxn>
-                      <a:cxn ang="0">
-                        <a:pos x="csX3" y="csY3"/>
-                      </a:cxn>
-                      <a:cxn ang="0">
-                        <a:pos x="csX4" y="csY4"/>
-                      </a:cxn>
-                    </a:cxnLst>
-                    <a:rect l="l" t="t" r="r" b="b"/>
-                    <a:pathLst>
-                      <a:path w="800644" h="124548">
-                        <a:moveTo>
-                          <a:pt x="212" y="62274"/>
-                        </a:moveTo>
-                        <a:cubicBezTo>
-                          <a:pt x="12065" y="41516"/>
-                          <a:pt x="546315" y="0"/>
-                          <a:pt x="679666" y="0"/>
-                        </a:cubicBezTo>
-                        <a:cubicBezTo>
-                          <a:pt x="813017" y="0"/>
-                          <a:pt x="800320" y="27881"/>
-                          <a:pt x="800320" y="62274"/>
-                        </a:cubicBezTo>
-                        <a:cubicBezTo>
-                          <a:pt x="800320" y="96667"/>
-                          <a:pt x="741897" y="124548"/>
-                          <a:pt x="608546" y="124548"/>
-                        </a:cubicBezTo>
-                        <a:cubicBezTo>
-                          <a:pt x="475195" y="124548"/>
-                          <a:pt x="-11641" y="83032"/>
-                          <a:pt x="212" y="62274"/>
-                        </a:cubicBezTo>
-                        <a:close/>
-                      </a:path>
-                    </a:pathLst>
-                  </a:custGeom>
-                  <ask:type>
-                    <ask:lineSketchScribble/>
-                  </ask:type>
-                </ask:lineSketchStyleProps>
-              </a:ext>
-            </a:extLst>
+            <a:tailEnd type="triangle"/>
           </a:ln>
         </p:spPr>
         <p:style>
           <a:lnRef idx="2">
-            <a:schemeClr val="accent1">
-              <a:shade val="15000"/>
-            </a:schemeClr>
+            <a:schemeClr val="accent1"/>
           </a:lnRef>
-          <a:fillRef idx="1">
+          <a:fillRef idx="0">
             <a:schemeClr val="accent1"/>
           </a:fillRef>
-          <a:effectRef idx="0">
+          <a:effectRef idx="1">
             <a:schemeClr val="accent1"/>
           </a:effectRef>
           <a:fontRef idx="minor">
-            <a:schemeClr val="lt1"/>
+            <a:schemeClr val="tx1"/>
           </a:fontRef>
         </p:style>
-        <p:txBody>
-          <a:bodyPr rtlCol="0" anchor="ctr"/>
-          <a:lstStyle/>
-          <a:p>
-            <a:pPr algn="ctr"/>
-            <a:endParaRPr lang="en-US"/>
-          </a:p>
-        </p:txBody>
-      </p:sp>
-      <p:sp>
-        <p:nvSpPr>
-          <p:cNvPr id="55" name="Oval 54">
-            <a:extLst>
-              <a:ext uri="{FF2B5EF4-FFF2-40B4-BE49-F238E27FC236}">
-                <a16:creationId xmlns:a16="http://schemas.microsoft.com/office/drawing/2014/main" id="{55BC6564-A315-A175-5718-675BB5B259A3}"/>
-              </a:ext>
-            </a:extLst>
-          </p:cNvPr>
-          <p:cNvSpPr/>
+      </p:cxnSp>
+      <p:cxnSp>
+        <p:nvCxnSpPr>
+          <p:cNvPr id="106" name="Straight Arrow Connector 105">
+            <a:extLst>
+              <a:ext uri="{FF2B5EF4-FFF2-40B4-BE49-F238E27FC236}">
+                <a16:creationId xmlns:a16="http://schemas.microsoft.com/office/drawing/2014/main" id="{535C747E-41F5-B337-4F38-6D5B900BF9B7}"/>
+              </a:ext>
+            </a:extLst>
+          </p:cNvPr>
+          <p:cNvCxnSpPr>
+            <a:cxnSpLocks/>
+          </p:cNvCxnSpPr>
           <p:nvPr/>
-        </p:nvSpPr>
+        </p:nvCxnSpPr>
         <p:spPr>
-          <a:xfrm rot="523167">
-            <a:off x="8151354" y="5350600"/>
-            <a:ext cx="211599" cy="94578"/>
+          <a:xfrm>
+            <a:off x="7767324" y="4810080"/>
+            <a:ext cx="0" cy="432927"/>
           </a:xfrm>
-          <a:custGeom>
+          <a:prstGeom prst="straightConnector1">
             <a:avLst/>
-            <a:gdLst>
-              <a:gd name="csX0" fmla="*/ 3765 w 211599"/>
-              <a:gd name="csY0" fmla="*/ 17005 h 94578"/>
-              <a:gd name="csX1" fmla="*/ 84822 w 211599"/>
-              <a:gd name="csY1" fmla="*/ 451 h 94578"/>
-              <a:gd name="csX2" fmla="*/ 211599 w 211599"/>
-              <a:gd name="csY2" fmla="*/ 27165 h 94578"/>
-              <a:gd name="csX3" fmla="*/ 34022 w 211599"/>
-              <a:gd name="csY3" fmla="*/ 94519 h 94578"/>
-              <a:gd name="csX4" fmla="*/ 3765 w 211599"/>
-              <a:gd name="csY4" fmla="*/ 17005 h 94578"/>
-            </a:gdLst>
-            <a:ahLst/>
-            <a:cxnLst>
-              <a:cxn ang="0">
-                <a:pos x="csX0" y="csY0"/>
-              </a:cxn>
-              <a:cxn ang="0">
-                <a:pos x="csX1" y="csY1"/>
-              </a:cxn>
-              <a:cxn ang="0">
-                <a:pos x="csX2" y="csY2"/>
-              </a:cxn>
-              <a:cxn ang="0">
-                <a:pos x="csX3" y="csY3"/>
-              </a:cxn>
-              <a:cxn ang="0">
-                <a:pos x="csX4" y="csY4"/>
-              </a:cxn>
-            </a:cxnLst>
-            <a:rect l="l" t="t" r="r" b="b"/>
-            <a:pathLst>
-              <a:path w="211599" h="94578" fill="none" extrusionOk="0">
-                <a:moveTo>
-                  <a:pt x="3765" y="17005"/>
-                </a:moveTo>
-                <a:cubicBezTo>
-                  <a:pt x="20427" y="2299"/>
-                  <a:pt x="54331" y="-9779"/>
-                  <a:pt x="84822" y="451"/>
-                </a:cubicBezTo>
-                <a:cubicBezTo>
-                  <a:pt x="117351" y="1821"/>
-                  <a:pt x="205311" y="-1307"/>
-                  <a:pt x="211599" y="27165"/>
-                </a:cubicBezTo>
-                <a:cubicBezTo>
-                  <a:pt x="210697" y="52953"/>
-                  <a:pt x="63447" y="103458"/>
-                  <a:pt x="34022" y="94519"/>
-                </a:cubicBezTo>
-                <a:cubicBezTo>
-                  <a:pt x="2463" y="94551"/>
-                  <a:pt x="-1142" y="33539"/>
-                  <a:pt x="3765" y="17005"/>
-                </a:cubicBezTo>
-                <a:close/>
-              </a:path>
-              <a:path w="211599" h="94578" stroke="0" extrusionOk="0">
-                <a:moveTo>
-                  <a:pt x="3765" y="17005"/>
-                </a:moveTo>
-                <a:cubicBezTo>
-                  <a:pt x="5298" y="-2950"/>
-                  <a:pt x="48622" y="-656"/>
-                  <a:pt x="84822" y="451"/>
-                </a:cubicBezTo>
-                <a:cubicBezTo>
-                  <a:pt x="124035" y="3107"/>
-                  <a:pt x="208821" y="-7140"/>
-                  <a:pt x="211599" y="27165"/>
-                </a:cubicBezTo>
-                <a:cubicBezTo>
-                  <a:pt x="204783" y="68214"/>
-                  <a:pt x="66906" y="105915"/>
-                  <a:pt x="34022" y="94519"/>
-                </a:cubicBezTo>
-                <a:cubicBezTo>
-                  <a:pt x="-4701" y="90592"/>
-                  <a:pt x="-850" y="34523"/>
-                  <a:pt x="3765" y="17005"/>
-                </a:cubicBezTo>
-                <a:close/>
-              </a:path>
-            </a:pathLst>
-          </a:custGeom>
-          <a:pattFill prst="dkUpDiag">
-            <a:fgClr>
-              <a:schemeClr val="accent1">
-                <a:lumMod val="20000"/>
-                <a:lumOff val="80000"/>
-              </a:schemeClr>
-            </a:fgClr>
-            <a:bgClr>
-              <a:schemeClr val="bg1"/>
-            </a:bgClr>
-          </a:pattFill>
+          </a:prstGeom>
           <a:ln>
             <a:solidFill>
-              <a:schemeClr val="accent1">
-                <a:lumMod val="60000"/>
-                <a:lumOff val="40000"/>
-              </a:schemeClr>
+              <a:srgbClr val="C00000"/>
             </a:solidFill>
-            <a:extLst>
-              <a:ext uri="{C807C97D-BFC1-408E-A445-0C87EB9F89A2}">
-                <ask:lineSketchStyleProps xmlns:ask="http://schemas.microsoft.com/office/drawing/2018/sketchyshapes" sd="1219033472">
-                  <a:custGeom>
-                    <a:avLst/>
-                    <a:gdLst>
-                      <a:gd name="csX0" fmla="*/ 0 w 223073"/>
-                      <a:gd name="csY0" fmla="*/ 62274 h 124547"/>
-                      <a:gd name="csX1" fmla="*/ 111537 w 223073"/>
-                      <a:gd name="csY1" fmla="*/ 0 h 124547"/>
-                      <a:gd name="csX2" fmla="*/ 223074 w 223073"/>
-                      <a:gd name="csY2" fmla="*/ 62274 h 124547"/>
-                      <a:gd name="csX3" fmla="*/ 111537 w 223073"/>
-                      <a:gd name="csY3" fmla="*/ 124548 h 124547"/>
-                      <a:gd name="csX4" fmla="*/ 0 w 223073"/>
-                      <a:gd name="csY4" fmla="*/ 62274 h 124547"/>
-                      <a:gd name="csX0" fmla="*/ 122 w 223196"/>
-                      <a:gd name="csY0" fmla="*/ 27446 h 89720"/>
-                      <a:gd name="csX1" fmla="*/ 96419 w 223196"/>
-                      <a:gd name="csY1" fmla="*/ 732 h 89720"/>
-                      <a:gd name="csX2" fmla="*/ 223196 w 223196"/>
-                      <a:gd name="csY2" fmla="*/ 27446 h 89720"/>
-                      <a:gd name="csX3" fmla="*/ 111659 w 223196"/>
-                      <a:gd name="csY3" fmla="*/ 89720 h 89720"/>
-                      <a:gd name="csX4" fmla="*/ 122 w 223196"/>
-                      <a:gd name="csY4" fmla="*/ 27446 h 89720"/>
-                      <a:gd name="csX0" fmla="*/ 5659 w 228733"/>
-                      <a:gd name="csY0" fmla="*/ 27446 h 94800"/>
-                      <a:gd name="csX1" fmla="*/ 101956 w 228733"/>
-                      <a:gd name="csY1" fmla="*/ 732 h 94800"/>
-                      <a:gd name="csX2" fmla="*/ 228733 w 228733"/>
-                      <a:gd name="csY2" fmla="*/ 27446 h 94800"/>
-                      <a:gd name="csX3" fmla="*/ 51156 w 228733"/>
-                      <a:gd name="csY3" fmla="*/ 94800 h 94800"/>
-                      <a:gd name="csX4" fmla="*/ 5659 w 228733"/>
-                      <a:gd name="csY4" fmla="*/ 27446 h 94800"/>
-                      <a:gd name="csX0" fmla="*/ 3765 w 211599"/>
-                      <a:gd name="csY0" fmla="*/ 17005 h 94578"/>
-                      <a:gd name="csX1" fmla="*/ 84822 w 211599"/>
-                      <a:gd name="csY1" fmla="*/ 451 h 94578"/>
-                      <a:gd name="csX2" fmla="*/ 211599 w 211599"/>
-                      <a:gd name="csY2" fmla="*/ 27165 h 94578"/>
-                      <a:gd name="csX3" fmla="*/ 34022 w 211599"/>
-                      <a:gd name="csY3" fmla="*/ 94519 h 94578"/>
-                      <a:gd name="csX4" fmla="*/ 3765 w 211599"/>
-                      <a:gd name="csY4" fmla="*/ 17005 h 94578"/>
-                    </a:gdLst>
-                    <a:ahLst/>
-                    <a:cxnLst>
-                      <a:cxn ang="0">
-                        <a:pos x="csX0" y="csY0"/>
-                      </a:cxn>
-                      <a:cxn ang="0">
-                        <a:pos x="csX1" y="csY1"/>
-                      </a:cxn>
-                      <a:cxn ang="0">
-                        <a:pos x="csX2" y="csY2"/>
-                      </a:cxn>
-                      <a:cxn ang="0">
-                        <a:pos x="csX3" y="csY3"/>
-                      </a:cxn>
-                      <a:cxn ang="0">
-                        <a:pos x="csX4" y="csY4"/>
-                      </a:cxn>
-                    </a:cxnLst>
-                    <a:rect l="l" t="t" r="r" b="b"/>
-                    <a:pathLst>
-                      <a:path w="211599" h="94578">
-                        <a:moveTo>
-                          <a:pt x="3765" y="17005"/>
-                        </a:moveTo>
-                        <a:cubicBezTo>
-                          <a:pt x="12232" y="1327"/>
-                          <a:pt x="50183" y="-1242"/>
-                          <a:pt x="84822" y="451"/>
-                        </a:cubicBezTo>
-                        <a:cubicBezTo>
-                          <a:pt x="119461" y="2144"/>
-                          <a:pt x="211599" y="-7228"/>
-                          <a:pt x="211599" y="27165"/>
-                        </a:cubicBezTo>
-                        <a:cubicBezTo>
-                          <a:pt x="211599" y="61558"/>
-                          <a:pt x="68661" y="96212"/>
-                          <a:pt x="34022" y="94519"/>
-                        </a:cubicBezTo>
-                        <a:cubicBezTo>
-                          <a:pt x="-617" y="92826"/>
-                          <a:pt x="-4702" y="32683"/>
-                          <a:pt x="3765" y="17005"/>
-                        </a:cubicBezTo>
-                        <a:close/>
-                      </a:path>
-                    </a:pathLst>
-                  </a:custGeom>
-                  <ask:type>
-                    <ask:lineSketchScribble/>
-                  </ask:type>
-                </ask:lineSketchStyleProps>
-              </a:ext>
-            </a:extLst>
+            <a:tailEnd type="triangle"/>
           </a:ln>
         </p:spPr>
         <p:style>
           <a:lnRef idx="2">
-            <a:schemeClr val="accent1">
-              <a:shade val="15000"/>
-            </a:schemeClr>
+            <a:schemeClr val="accent1"/>
           </a:lnRef>
-          <a:fillRef idx="1">
+          <a:fillRef idx="0">
             <a:schemeClr val="accent1"/>
           </a:fillRef>
-          <a:effectRef idx="0">
+          <a:effectRef idx="1">
             <a:schemeClr val="accent1"/>
           </a:effectRef>
           <a:fontRef idx="minor">
-            <a:schemeClr val="lt1"/>
+            <a:schemeClr val="tx1"/>
           </a:fontRef>
         </p:style>
-        <p:txBody>
-          <a:bodyPr rtlCol="0" anchor="ctr"/>
+      </p:cxnSp>
+      <p:sp>
+        <p:nvSpPr>
+          <p:cNvPr id="126" name="TextBox 125">
+            <a:extLst>
+              <a:ext uri="{FF2B5EF4-FFF2-40B4-BE49-F238E27FC236}">
+                <a16:creationId xmlns:a16="http://schemas.microsoft.com/office/drawing/2014/main" id="{A49FE8C5-611C-B268-338D-9B9F892DD772}"/>
+              </a:ext>
+            </a:extLst>
+          </p:cNvPr>
+          <p:cNvSpPr txBox="1"/>
+          <p:nvPr/>
+        </p:nvSpPr>
+        <p:spPr>
+          <a:xfrm>
+            <a:off x="7018625" y="4152612"/>
+            <a:ext cx="671580" cy="523220"/>
+          </a:xfrm>
+          <a:prstGeom prst="rect">
+            <a:avLst/>
+          </a:prstGeom>
+          <a:noFill/>
+        </p:spPr>
+        <p:txBody>
+          <a:bodyPr wrap="square" rtlCol="0" anchor="ctr">
+            <a:spAutoFit/>
+          </a:bodyPr>
           <a:lstStyle/>
           <a:p>
-            <a:pPr algn="ctr"/>
-            <a:endParaRPr lang="en-US"/>
-          </a:p>
-        </p:txBody>
-      </p:sp>
-      <p:sp>
-        <p:nvSpPr>
-          <p:cNvPr id="79" name="Freeform 78">
-            <a:extLst>
-              <a:ext uri="{FF2B5EF4-FFF2-40B4-BE49-F238E27FC236}">
-                <a16:creationId xmlns:a16="http://schemas.microsoft.com/office/drawing/2014/main" id="{9BFE1455-5F70-9CA9-B90D-4975B02B9C9E}"/>
-              </a:ext>
-            </a:extLst>
-          </p:cNvPr>
-          <p:cNvSpPr/>
+            <a:r>
+              <a:rPr lang="en-US" sz="1400" dirty="0">
+                <a:latin typeface=""/>
+              </a:rPr>
+              <a:t>thaw slump</a:t>
+            </a:r>
+          </a:p>
+        </p:txBody>
+      </p:sp>
+      <p:sp>
+        <p:nvSpPr>
+          <p:cNvPr id="127" name="TextBox 126">
+            <a:extLst>
+              <a:ext uri="{FF2B5EF4-FFF2-40B4-BE49-F238E27FC236}">
+                <a16:creationId xmlns:a16="http://schemas.microsoft.com/office/drawing/2014/main" id="{3049991D-FAD2-BE5D-BA16-5C97D5D73114}"/>
+              </a:ext>
+            </a:extLst>
+          </p:cNvPr>
+          <p:cNvSpPr txBox="1"/>
           <p:nvPr/>
         </p:nvSpPr>
         <p:spPr>
-          <a:xfrm rot="583769">
-            <a:off x="8099080" y="5420291"/>
-            <a:ext cx="1479411" cy="649802"/>
+          <a:xfrm>
+            <a:off x="9363905" y="4687793"/>
+            <a:ext cx="966299" cy="307777"/>
           </a:xfrm>
-          <a:custGeom>
+          <a:prstGeom prst="rect">
             <a:avLst/>
-            <a:gdLst>
-              <a:gd name="csX0" fmla="*/ 0 w 3455582"/>
-              <a:gd name="csY0" fmla="*/ 212977 h 319302"/>
-              <a:gd name="csX1" fmla="*/ 499730 w 3455582"/>
-              <a:gd name="csY1" fmla="*/ 325 h 319302"/>
-              <a:gd name="csX2" fmla="*/ 978196 w 3455582"/>
-              <a:gd name="csY2" fmla="*/ 255507 h 319302"/>
-              <a:gd name="csX3" fmla="*/ 1371600 w 3455582"/>
-              <a:gd name="csY3" fmla="*/ 10958 h 319302"/>
-              <a:gd name="csX4" fmla="*/ 1743740 w 3455582"/>
-              <a:gd name="csY4" fmla="*/ 255507 h 319302"/>
-              <a:gd name="csX5" fmla="*/ 2126512 w 3455582"/>
-              <a:gd name="csY5" fmla="*/ 32223 h 319302"/>
-              <a:gd name="csX6" fmla="*/ 2562447 w 3455582"/>
-              <a:gd name="csY6" fmla="*/ 298037 h 319302"/>
-              <a:gd name="csX7" fmla="*/ 3051544 w 3455582"/>
-              <a:gd name="csY7" fmla="*/ 64121 h 319302"/>
-              <a:gd name="csX8" fmla="*/ 3455582 w 3455582"/>
-              <a:gd name="csY8" fmla="*/ 319302 h 319302"/>
-              <a:gd name="csX0" fmla="*/ 0 w 3455582"/>
-              <a:gd name="csY0" fmla="*/ 218043 h 324368"/>
-              <a:gd name="csX1" fmla="*/ 499730 w 3455582"/>
-              <a:gd name="csY1" fmla="*/ 5391 h 324368"/>
-              <a:gd name="csX2" fmla="*/ 834136 w 3455582"/>
-              <a:gd name="csY2" fmla="*/ 59721 h 324368"/>
-              <a:gd name="csX3" fmla="*/ 1371600 w 3455582"/>
-              <a:gd name="csY3" fmla="*/ 16024 h 324368"/>
-              <a:gd name="csX4" fmla="*/ 1743740 w 3455582"/>
-              <a:gd name="csY4" fmla="*/ 260573 h 324368"/>
-              <a:gd name="csX5" fmla="*/ 2126512 w 3455582"/>
-              <a:gd name="csY5" fmla="*/ 37289 h 324368"/>
-              <a:gd name="csX6" fmla="*/ 2562447 w 3455582"/>
-              <a:gd name="csY6" fmla="*/ 303103 h 324368"/>
-              <a:gd name="csX7" fmla="*/ 3051544 w 3455582"/>
-              <a:gd name="csY7" fmla="*/ 69187 h 324368"/>
-              <a:gd name="csX8" fmla="*/ 3455582 w 3455582"/>
-              <a:gd name="csY8" fmla="*/ 324368 h 324368"/>
-              <a:gd name="csX0" fmla="*/ 0 w 2955852"/>
-              <a:gd name="csY0" fmla="*/ 5391 h 324368"/>
-              <a:gd name="csX1" fmla="*/ 334406 w 2955852"/>
-              <a:gd name="csY1" fmla="*/ 59721 h 324368"/>
-              <a:gd name="csX2" fmla="*/ 871870 w 2955852"/>
-              <a:gd name="csY2" fmla="*/ 16024 h 324368"/>
-              <a:gd name="csX3" fmla="*/ 1244010 w 2955852"/>
-              <a:gd name="csY3" fmla="*/ 260573 h 324368"/>
-              <a:gd name="csX4" fmla="*/ 1626782 w 2955852"/>
-              <a:gd name="csY4" fmla="*/ 37289 h 324368"/>
-              <a:gd name="csX5" fmla="*/ 2062717 w 2955852"/>
-              <a:gd name="csY5" fmla="*/ 303103 h 324368"/>
-              <a:gd name="csX6" fmla="*/ 2551814 w 2955852"/>
-              <a:gd name="csY6" fmla="*/ 69187 h 324368"/>
-              <a:gd name="csX7" fmla="*/ 2955852 w 2955852"/>
-              <a:gd name="csY7" fmla="*/ 324368 h 324368"/>
-              <a:gd name="csX0" fmla="*/ 0 w 2621446"/>
-              <a:gd name="csY0" fmla="*/ 51978 h 316625"/>
-              <a:gd name="csX1" fmla="*/ 537464 w 2621446"/>
-              <a:gd name="csY1" fmla="*/ 8281 h 316625"/>
-              <a:gd name="csX2" fmla="*/ 909604 w 2621446"/>
-              <a:gd name="csY2" fmla="*/ 252830 h 316625"/>
-              <a:gd name="csX3" fmla="*/ 1292376 w 2621446"/>
-              <a:gd name="csY3" fmla="*/ 29546 h 316625"/>
-              <a:gd name="csX4" fmla="*/ 1728311 w 2621446"/>
-              <a:gd name="csY4" fmla="*/ 295360 h 316625"/>
-              <a:gd name="csX5" fmla="*/ 2217408 w 2621446"/>
-              <a:gd name="csY5" fmla="*/ 61444 h 316625"/>
-              <a:gd name="csX6" fmla="*/ 2621446 w 2621446"/>
-              <a:gd name="csY6" fmla="*/ 316625 h 316625"/>
-              <a:gd name="csX0" fmla="*/ 0 w 2396848"/>
-              <a:gd name="csY0" fmla="*/ 28441 h 321940"/>
-              <a:gd name="csX1" fmla="*/ 312866 w 2396848"/>
-              <a:gd name="csY1" fmla="*/ 13596 h 321940"/>
-              <a:gd name="csX2" fmla="*/ 685006 w 2396848"/>
-              <a:gd name="csY2" fmla="*/ 258145 h 321940"/>
-              <a:gd name="csX3" fmla="*/ 1067778 w 2396848"/>
-              <a:gd name="csY3" fmla="*/ 34861 h 321940"/>
-              <a:gd name="csX4" fmla="*/ 1503713 w 2396848"/>
-              <a:gd name="csY4" fmla="*/ 300675 h 321940"/>
-              <a:gd name="csX5" fmla="*/ 1992810 w 2396848"/>
-              <a:gd name="csY5" fmla="*/ 66759 h 321940"/>
-              <a:gd name="csX6" fmla="*/ 2396848 w 2396848"/>
-              <a:gd name="csY6" fmla="*/ 321940 h 321940"/>
-              <a:gd name="csX0" fmla="*/ 0 w 2376820"/>
-              <a:gd name="csY0" fmla="*/ 22671 h 323946"/>
-              <a:gd name="csX1" fmla="*/ 292838 w 2376820"/>
-              <a:gd name="csY1" fmla="*/ 15602 h 323946"/>
-              <a:gd name="csX2" fmla="*/ 664978 w 2376820"/>
-              <a:gd name="csY2" fmla="*/ 260151 h 323946"/>
-              <a:gd name="csX3" fmla="*/ 1047750 w 2376820"/>
-              <a:gd name="csY3" fmla="*/ 36867 h 323946"/>
-              <a:gd name="csX4" fmla="*/ 1483685 w 2376820"/>
-              <a:gd name="csY4" fmla="*/ 302681 h 323946"/>
-              <a:gd name="csX5" fmla="*/ 1972782 w 2376820"/>
-              <a:gd name="csY5" fmla="*/ 68765 h 323946"/>
-              <a:gd name="csX6" fmla="*/ 2376820 w 2376820"/>
-              <a:gd name="csY6" fmla="*/ 323946 h 323946"/>
-              <a:gd name="csX0" fmla="*/ 0 w 1972782"/>
-              <a:gd name="csY0" fmla="*/ 22671 h 302767"/>
-              <a:gd name="csX1" fmla="*/ 292838 w 1972782"/>
-              <a:gd name="csY1" fmla="*/ 15602 h 302767"/>
-              <a:gd name="csX2" fmla="*/ 664978 w 1972782"/>
-              <a:gd name="csY2" fmla="*/ 260151 h 302767"/>
-              <a:gd name="csX3" fmla="*/ 1047750 w 1972782"/>
-              <a:gd name="csY3" fmla="*/ 36867 h 302767"/>
-              <a:gd name="csX4" fmla="*/ 1483685 w 1972782"/>
-              <a:gd name="csY4" fmla="*/ 302681 h 302767"/>
-              <a:gd name="csX5" fmla="*/ 1972782 w 1972782"/>
-              <a:gd name="csY5" fmla="*/ 68765 h 302767"/>
-              <a:gd name="csX0" fmla="*/ 0 w 1483685"/>
-              <a:gd name="csY0" fmla="*/ 22671 h 302681"/>
-              <a:gd name="csX1" fmla="*/ 292838 w 1483685"/>
-              <a:gd name="csY1" fmla="*/ 15602 h 302681"/>
-              <a:gd name="csX2" fmla="*/ 664978 w 1483685"/>
-              <a:gd name="csY2" fmla="*/ 260151 h 302681"/>
-              <a:gd name="csX3" fmla="*/ 1047750 w 1483685"/>
-              <a:gd name="csY3" fmla="*/ 36867 h 302681"/>
-              <a:gd name="csX4" fmla="*/ 1483685 w 1483685"/>
-              <a:gd name="csY4" fmla="*/ 302681 h 302681"/>
-              <a:gd name="csX0" fmla="*/ 0 w 1479410"/>
-              <a:gd name="csY0" fmla="*/ 39882 h 1488779"/>
-              <a:gd name="csX1" fmla="*/ 292838 w 1479410"/>
-              <a:gd name="csY1" fmla="*/ 32813 h 1488779"/>
-              <a:gd name="csX2" fmla="*/ 664978 w 1479410"/>
-              <a:gd name="csY2" fmla="*/ 277362 h 1488779"/>
-              <a:gd name="csX3" fmla="*/ 1047750 w 1479410"/>
-              <a:gd name="csY3" fmla="*/ 54078 h 1488779"/>
-              <a:gd name="csX4" fmla="*/ 1479410 w 1479410"/>
-              <a:gd name="csY4" fmla="*/ 1488778 h 1488779"/>
-              <a:gd name="csX0" fmla="*/ 0 w 1479410"/>
-              <a:gd name="csY0" fmla="*/ 22673 h 1471570"/>
-              <a:gd name="csX1" fmla="*/ 292838 w 1479410"/>
-              <a:gd name="csY1" fmla="*/ 15604 h 1471570"/>
-              <a:gd name="csX2" fmla="*/ 664978 w 1479410"/>
-              <a:gd name="csY2" fmla="*/ 260153 h 1471570"/>
-              <a:gd name="csX3" fmla="*/ 1109694 w 1479410"/>
-              <a:gd name="csY3" fmla="*/ 106194 h 1471570"/>
-              <a:gd name="csX4" fmla="*/ 1479410 w 1479410"/>
-              <a:gd name="csY4" fmla="*/ 1471569 h 1471570"/>
-            </a:gdLst>
-            <a:ahLst/>
-            <a:cxnLst>
-              <a:cxn ang="0">
-                <a:pos x="csX0" y="csY0"/>
-              </a:cxn>
-              <a:cxn ang="0">
-                <a:pos x="csX1" y="csY1"/>
-              </a:cxn>
-              <a:cxn ang="0">
-                <a:pos x="csX2" y="csY2"/>
-              </a:cxn>
-              <a:cxn ang="0">
-                <a:pos x="csX3" y="csY3"/>
-              </a:cxn>
-              <a:cxn ang="0">
-                <a:pos x="csX4" y="csY4"/>
-              </a:cxn>
-            </a:cxnLst>
-            <a:rect l="l" t="t" r="r" b="b"/>
-            <a:pathLst>
-              <a:path w="1479410" h="1471570">
-                <a:moveTo>
-                  <a:pt x="0" y="22673"/>
-                </a:moveTo>
-                <a:cubicBezTo>
-                  <a:pt x="145312" y="24445"/>
-                  <a:pt x="182008" y="-23976"/>
-                  <a:pt x="292838" y="15604"/>
-                </a:cubicBezTo>
-                <a:cubicBezTo>
-                  <a:pt x="403668" y="55184"/>
-                  <a:pt x="528835" y="245055"/>
-                  <a:pt x="664978" y="260153"/>
-                </a:cubicBezTo>
-                <a:cubicBezTo>
-                  <a:pt x="801121" y="275251"/>
-                  <a:pt x="973955" y="-95709"/>
-                  <a:pt x="1109694" y="106194"/>
-                </a:cubicBezTo>
-                <a:cubicBezTo>
-                  <a:pt x="1245433" y="308097"/>
-                  <a:pt x="1325238" y="1466253"/>
-                  <a:pt x="1479410" y="1471569"/>
-                </a:cubicBezTo>
-              </a:path>
-            </a:pathLst>
-          </a:custGeom>
+          </a:prstGeom>
           <a:noFill/>
-          <a:ln w="28575">
+        </p:spPr>
+        <p:txBody>
+          <a:bodyPr wrap="square" rtlCol="0" anchor="ctr">
+            <a:spAutoFit/>
+          </a:bodyPr>
+          <a:lstStyle/>
+          <a:p>
+            <a:r>
+              <a:rPr lang="en-US" sz="1400" dirty="0">
+                <a:latin typeface=""/>
+              </a:rPr>
+              <a:t>thaw lake</a:t>
+            </a:r>
+          </a:p>
+        </p:txBody>
+      </p:sp>
+      <p:sp>
+        <p:nvSpPr>
+          <p:cNvPr id="128" name="TextBox 127">
+            <a:extLst>
+              <a:ext uri="{FF2B5EF4-FFF2-40B4-BE49-F238E27FC236}">
+                <a16:creationId xmlns:a16="http://schemas.microsoft.com/office/drawing/2014/main" id="{917590A1-F467-FE4E-D015-903312140A4E}"/>
+              </a:ext>
+            </a:extLst>
+          </p:cNvPr>
+          <p:cNvSpPr txBox="1"/>
+          <p:nvPr/>
+        </p:nvSpPr>
+        <p:spPr>
+          <a:xfrm>
+            <a:off x="8626207" y="3903194"/>
+            <a:ext cx="1900939" cy="523220"/>
+          </a:xfrm>
+          <a:prstGeom prst="rect">
+            <a:avLst/>
+          </a:prstGeom>
+          <a:noFill/>
+        </p:spPr>
+        <p:txBody>
+          <a:bodyPr wrap="square" rtlCol="0" anchor="ctr">
+            <a:spAutoFit/>
+          </a:bodyPr>
+          <a:lstStyle/>
+          <a:p>
+            <a:pPr algn="r"/>
+            <a:r>
+              <a:rPr lang="en-US" sz="1400" dirty="0">
+                <a:latin typeface=""/>
+              </a:rPr>
+              <a:t>pronounced surface reorganization</a:t>
+            </a:r>
+          </a:p>
+        </p:txBody>
+      </p:sp>
+      <p:sp>
+        <p:nvSpPr>
+          <p:cNvPr id="129" name="TextBox 128">
+            <a:extLst>
+              <a:ext uri="{FF2B5EF4-FFF2-40B4-BE49-F238E27FC236}">
+                <a16:creationId xmlns:a16="http://schemas.microsoft.com/office/drawing/2014/main" id="{6918110C-73C3-D855-589B-C66BBB9F0868}"/>
+              </a:ext>
+            </a:extLst>
+          </p:cNvPr>
+          <p:cNvSpPr txBox="1"/>
+          <p:nvPr/>
+        </p:nvSpPr>
+        <p:spPr>
+          <a:xfrm>
+            <a:off x="9479579" y="5621428"/>
+            <a:ext cx="527958" cy="307777"/>
+          </a:xfrm>
+          <a:prstGeom prst="rect">
+            <a:avLst/>
+          </a:prstGeom>
+          <a:noFill/>
+        </p:spPr>
+        <p:txBody>
+          <a:bodyPr wrap="square" rtlCol="0" anchor="ctr">
+            <a:spAutoFit/>
+          </a:bodyPr>
+          <a:lstStyle/>
+          <a:p>
+            <a:r>
+              <a:rPr lang="en-US" sz="1400" dirty="0">
+                <a:latin typeface=""/>
+              </a:rPr>
+              <a:t>talik</a:t>
+            </a:r>
+          </a:p>
+        </p:txBody>
+      </p:sp>
+      <p:sp>
+        <p:nvSpPr>
+          <p:cNvPr id="130" name="TextBox 129">
+            <a:extLst>
+              <a:ext uri="{FF2B5EF4-FFF2-40B4-BE49-F238E27FC236}">
+                <a16:creationId xmlns:a16="http://schemas.microsoft.com/office/drawing/2014/main" id="{051CD7BD-2A55-7AF8-BB0B-708A993A5F49}"/>
+              </a:ext>
+            </a:extLst>
+          </p:cNvPr>
+          <p:cNvSpPr txBox="1"/>
+          <p:nvPr/>
+        </p:nvSpPr>
+        <p:spPr>
+          <a:xfrm>
+            <a:off x="7211530" y="5500518"/>
+            <a:ext cx="1573805" cy="523220"/>
+          </a:xfrm>
+          <a:prstGeom prst="rect">
+            <a:avLst/>
+          </a:prstGeom>
+          <a:noFill/>
+        </p:spPr>
+        <p:txBody>
+          <a:bodyPr wrap="square" rtlCol="0" anchor="ctr">
+            <a:spAutoFit/>
+          </a:bodyPr>
+          <a:lstStyle/>
+          <a:p>
+            <a:r>
+              <a:rPr lang="en-US" sz="1400" dirty="0">
+                <a:latin typeface=""/>
+              </a:rPr>
+              <a:t>excess ground ice consumed</a:t>
+            </a:r>
+          </a:p>
+        </p:txBody>
+      </p:sp>
+      <p:cxnSp>
+        <p:nvCxnSpPr>
+          <p:cNvPr id="131" name="Straight Arrow Connector 130">
+            <a:extLst>
+              <a:ext uri="{FF2B5EF4-FFF2-40B4-BE49-F238E27FC236}">
+                <a16:creationId xmlns:a16="http://schemas.microsoft.com/office/drawing/2014/main" id="{14A9FD15-38FF-D972-DB4F-3BBB47D451CA}"/>
+              </a:ext>
+            </a:extLst>
+          </p:cNvPr>
+          <p:cNvCxnSpPr>
+            <a:cxnSpLocks/>
+          </p:cNvCxnSpPr>
+          <p:nvPr/>
+        </p:nvCxnSpPr>
+        <p:spPr>
+          <a:xfrm>
+            <a:off x="10103949" y="5318411"/>
+            <a:ext cx="3874" cy="872017"/>
+          </a:xfrm>
+          <a:prstGeom prst="straightConnector1">
+            <a:avLst/>
+          </a:prstGeom>
+          <a:ln>
             <a:solidFill>
               <a:srgbClr val="C00000"/>
             </a:solidFill>
-            <a:prstDash val="solid"/>
+            <a:tailEnd type="triangle"/>
           </a:ln>
         </p:spPr>
         <p:style>
           <a:lnRef idx="2">
-            <a:schemeClr val="accent1">
-              <a:shade val="15000"/>
-            </a:schemeClr>
+            <a:schemeClr val="accent1"/>
           </a:lnRef>
-          <a:fillRef idx="1">
+          <a:fillRef idx="0">
             <a:schemeClr val="accent1"/>
           </a:fillRef>
-          <a:effectRef idx="0">
+          <a:effectRef idx="1">
             <a:schemeClr val="accent1"/>
           </a:effectRef>
           <a:fontRef idx="minor">
-            <a:schemeClr val="lt1"/>
+            <a:schemeClr val="tx1"/>
           </a:fontRef>
         </p:style>
-        <p:txBody>
-          <a:bodyPr rtlCol="0" anchor="ctr"/>
-          <a:lstStyle/>
-          <a:p>
-            <a:pPr algn="ctr"/>
-            <a:endParaRPr lang="en-US"/>
-          </a:p>
-        </p:txBody>
-      </p:sp>
-      <p:sp>
-        <p:nvSpPr>
-          <p:cNvPr id="80" name="Freeform 79">
-            <a:extLst>
-              <a:ext uri="{FF2B5EF4-FFF2-40B4-BE49-F238E27FC236}">
-                <a16:creationId xmlns:a16="http://schemas.microsoft.com/office/drawing/2014/main" id="{5E2B6793-6B9C-BDD2-E9E0-21CBDFA7F9EA}"/>
-              </a:ext>
-            </a:extLst>
-          </p:cNvPr>
-          <p:cNvSpPr/>
-          <p:nvPr/>
-        </p:nvSpPr>
-        <p:spPr>
-          <a:xfrm rot="583769">
-            <a:off x="10336818" y="5890313"/>
-            <a:ext cx="130645" cy="309477"/>
-          </a:xfrm>
-          <a:custGeom>
-            <a:avLst/>
-            <a:gdLst>
-              <a:gd name="csX0" fmla="*/ 0 w 3455582"/>
-              <a:gd name="csY0" fmla="*/ 212977 h 319302"/>
-              <a:gd name="csX1" fmla="*/ 499730 w 3455582"/>
-              <a:gd name="csY1" fmla="*/ 325 h 319302"/>
-              <a:gd name="csX2" fmla="*/ 978196 w 3455582"/>
-              <a:gd name="csY2" fmla="*/ 255507 h 319302"/>
-              <a:gd name="csX3" fmla="*/ 1371600 w 3455582"/>
-              <a:gd name="csY3" fmla="*/ 10958 h 319302"/>
-              <a:gd name="csX4" fmla="*/ 1743740 w 3455582"/>
-              <a:gd name="csY4" fmla="*/ 255507 h 319302"/>
-              <a:gd name="csX5" fmla="*/ 2126512 w 3455582"/>
-              <a:gd name="csY5" fmla="*/ 32223 h 319302"/>
-              <a:gd name="csX6" fmla="*/ 2562447 w 3455582"/>
-              <a:gd name="csY6" fmla="*/ 298037 h 319302"/>
-              <a:gd name="csX7" fmla="*/ 3051544 w 3455582"/>
-              <a:gd name="csY7" fmla="*/ 64121 h 319302"/>
-              <a:gd name="csX8" fmla="*/ 3455582 w 3455582"/>
-              <a:gd name="csY8" fmla="*/ 319302 h 319302"/>
-              <a:gd name="csX0" fmla="*/ 0 w 3455582"/>
-              <a:gd name="csY0" fmla="*/ 218043 h 324368"/>
-              <a:gd name="csX1" fmla="*/ 499730 w 3455582"/>
-              <a:gd name="csY1" fmla="*/ 5391 h 324368"/>
-              <a:gd name="csX2" fmla="*/ 834136 w 3455582"/>
-              <a:gd name="csY2" fmla="*/ 59721 h 324368"/>
-              <a:gd name="csX3" fmla="*/ 1371600 w 3455582"/>
-              <a:gd name="csY3" fmla="*/ 16024 h 324368"/>
-              <a:gd name="csX4" fmla="*/ 1743740 w 3455582"/>
-              <a:gd name="csY4" fmla="*/ 260573 h 324368"/>
-              <a:gd name="csX5" fmla="*/ 2126512 w 3455582"/>
-              <a:gd name="csY5" fmla="*/ 37289 h 324368"/>
-              <a:gd name="csX6" fmla="*/ 2562447 w 3455582"/>
-              <a:gd name="csY6" fmla="*/ 303103 h 324368"/>
-              <a:gd name="csX7" fmla="*/ 3051544 w 3455582"/>
-              <a:gd name="csY7" fmla="*/ 69187 h 324368"/>
-              <a:gd name="csX8" fmla="*/ 3455582 w 3455582"/>
-              <a:gd name="csY8" fmla="*/ 324368 h 324368"/>
-              <a:gd name="csX0" fmla="*/ 0 w 2955852"/>
-              <a:gd name="csY0" fmla="*/ 5391 h 324368"/>
-              <a:gd name="csX1" fmla="*/ 334406 w 2955852"/>
-              <a:gd name="csY1" fmla="*/ 59721 h 324368"/>
-              <a:gd name="csX2" fmla="*/ 871870 w 2955852"/>
-              <a:gd name="csY2" fmla="*/ 16024 h 324368"/>
-              <a:gd name="csX3" fmla="*/ 1244010 w 2955852"/>
-              <a:gd name="csY3" fmla="*/ 260573 h 324368"/>
-              <a:gd name="csX4" fmla="*/ 1626782 w 2955852"/>
-              <a:gd name="csY4" fmla="*/ 37289 h 324368"/>
-              <a:gd name="csX5" fmla="*/ 2062717 w 2955852"/>
-              <a:gd name="csY5" fmla="*/ 303103 h 324368"/>
-              <a:gd name="csX6" fmla="*/ 2551814 w 2955852"/>
-              <a:gd name="csY6" fmla="*/ 69187 h 324368"/>
-              <a:gd name="csX7" fmla="*/ 2955852 w 2955852"/>
-              <a:gd name="csY7" fmla="*/ 324368 h 324368"/>
-              <a:gd name="csX0" fmla="*/ 0 w 2621446"/>
-              <a:gd name="csY0" fmla="*/ 51978 h 316625"/>
-              <a:gd name="csX1" fmla="*/ 537464 w 2621446"/>
-              <a:gd name="csY1" fmla="*/ 8281 h 316625"/>
-              <a:gd name="csX2" fmla="*/ 909604 w 2621446"/>
-              <a:gd name="csY2" fmla="*/ 252830 h 316625"/>
-              <a:gd name="csX3" fmla="*/ 1292376 w 2621446"/>
-              <a:gd name="csY3" fmla="*/ 29546 h 316625"/>
-              <a:gd name="csX4" fmla="*/ 1728311 w 2621446"/>
-              <a:gd name="csY4" fmla="*/ 295360 h 316625"/>
-              <a:gd name="csX5" fmla="*/ 2217408 w 2621446"/>
-              <a:gd name="csY5" fmla="*/ 61444 h 316625"/>
-              <a:gd name="csX6" fmla="*/ 2621446 w 2621446"/>
-              <a:gd name="csY6" fmla="*/ 316625 h 316625"/>
-              <a:gd name="csX0" fmla="*/ 0 w 2396848"/>
-              <a:gd name="csY0" fmla="*/ 28441 h 321940"/>
-              <a:gd name="csX1" fmla="*/ 312866 w 2396848"/>
-              <a:gd name="csY1" fmla="*/ 13596 h 321940"/>
-              <a:gd name="csX2" fmla="*/ 685006 w 2396848"/>
-              <a:gd name="csY2" fmla="*/ 258145 h 321940"/>
-              <a:gd name="csX3" fmla="*/ 1067778 w 2396848"/>
-              <a:gd name="csY3" fmla="*/ 34861 h 321940"/>
-              <a:gd name="csX4" fmla="*/ 1503713 w 2396848"/>
-              <a:gd name="csY4" fmla="*/ 300675 h 321940"/>
-              <a:gd name="csX5" fmla="*/ 1992810 w 2396848"/>
-              <a:gd name="csY5" fmla="*/ 66759 h 321940"/>
-              <a:gd name="csX6" fmla="*/ 2396848 w 2396848"/>
-              <a:gd name="csY6" fmla="*/ 321940 h 321940"/>
-              <a:gd name="csX0" fmla="*/ 0 w 2376820"/>
-              <a:gd name="csY0" fmla="*/ 22671 h 323946"/>
-              <a:gd name="csX1" fmla="*/ 292838 w 2376820"/>
-              <a:gd name="csY1" fmla="*/ 15602 h 323946"/>
-              <a:gd name="csX2" fmla="*/ 664978 w 2376820"/>
-              <a:gd name="csY2" fmla="*/ 260151 h 323946"/>
-              <a:gd name="csX3" fmla="*/ 1047750 w 2376820"/>
-              <a:gd name="csY3" fmla="*/ 36867 h 323946"/>
-              <a:gd name="csX4" fmla="*/ 1483685 w 2376820"/>
-              <a:gd name="csY4" fmla="*/ 302681 h 323946"/>
-              <a:gd name="csX5" fmla="*/ 1972782 w 2376820"/>
-              <a:gd name="csY5" fmla="*/ 68765 h 323946"/>
-              <a:gd name="csX6" fmla="*/ 2376820 w 2376820"/>
-              <a:gd name="csY6" fmla="*/ 323946 h 323946"/>
-              <a:gd name="csX0" fmla="*/ 0 w 2083982"/>
-              <a:gd name="csY0" fmla="*/ 1 h 308345"/>
-              <a:gd name="csX1" fmla="*/ 372140 w 2083982"/>
-              <a:gd name="csY1" fmla="*/ 244550 h 308345"/>
-              <a:gd name="csX2" fmla="*/ 754912 w 2083982"/>
-              <a:gd name="csY2" fmla="*/ 21266 h 308345"/>
-              <a:gd name="csX3" fmla="*/ 1190847 w 2083982"/>
-              <a:gd name="csY3" fmla="*/ 287080 h 308345"/>
-              <a:gd name="csX4" fmla="*/ 1679944 w 2083982"/>
-              <a:gd name="csY4" fmla="*/ 53164 h 308345"/>
-              <a:gd name="csX5" fmla="*/ 2083982 w 2083982"/>
-              <a:gd name="csY5" fmla="*/ 308345 h 308345"/>
-              <a:gd name="csX0" fmla="*/ 0 w 1711842"/>
-              <a:gd name="csY0" fmla="*/ 223441 h 287236"/>
-              <a:gd name="csX1" fmla="*/ 382772 w 1711842"/>
-              <a:gd name="csY1" fmla="*/ 157 h 287236"/>
-              <a:gd name="csX2" fmla="*/ 818707 w 1711842"/>
-              <a:gd name="csY2" fmla="*/ 265971 h 287236"/>
-              <a:gd name="csX3" fmla="*/ 1307804 w 1711842"/>
-              <a:gd name="csY3" fmla="*/ 32055 h 287236"/>
-              <a:gd name="csX4" fmla="*/ 1711842 w 1711842"/>
-              <a:gd name="csY4" fmla="*/ 287236 h 287236"/>
-              <a:gd name="csX0" fmla="*/ 0 w 1329070"/>
-              <a:gd name="csY0" fmla="*/ 1 h 287080"/>
-              <a:gd name="csX1" fmla="*/ 435935 w 1329070"/>
-              <a:gd name="csY1" fmla="*/ 265815 h 287080"/>
-              <a:gd name="csX2" fmla="*/ 925032 w 1329070"/>
-              <a:gd name="csY2" fmla="*/ 31899 h 287080"/>
-              <a:gd name="csX3" fmla="*/ 1329070 w 1329070"/>
-              <a:gd name="csY3" fmla="*/ 287080 h 287080"/>
-              <a:gd name="csX0" fmla="*/ 0 w 893135"/>
-              <a:gd name="csY0" fmla="*/ 233956 h 255221"/>
-              <a:gd name="csX1" fmla="*/ 489097 w 893135"/>
-              <a:gd name="csY1" fmla="*/ 40 h 255221"/>
-              <a:gd name="csX2" fmla="*/ 893135 w 893135"/>
-              <a:gd name="csY2" fmla="*/ 255221 h 255221"/>
-              <a:gd name="csX0" fmla="*/ 0 w 404038"/>
-              <a:gd name="csY0" fmla="*/ -1 h 255180"/>
-              <a:gd name="csX1" fmla="*/ 404038 w 404038"/>
-              <a:gd name="csY1" fmla="*/ 255180 h 255180"/>
-              <a:gd name="csX0" fmla="*/ 0 w 124491"/>
-              <a:gd name="csY0" fmla="*/ 861348 h 861357"/>
-              <a:gd name="csX1" fmla="*/ 124491 w 124491"/>
-              <a:gd name="csY1" fmla="*/ 11160 h 861357"/>
-              <a:gd name="csX0" fmla="*/ 0 w 150102"/>
-              <a:gd name="csY0" fmla="*/ 594958 h 594972"/>
-              <a:gd name="csX1" fmla="*/ 150102 w 150102"/>
-              <a:gd name="csY1" fmla="*/ 14960 h 594972"/>
-              <a:gd name="csX0" fmla="*/ 0 w 130645"/>
-              <a:gd name="csY0" fmla="*/ 713820 h 713832"/>
-              <a:gd name="csX1" fmla="*/ 130645 w 130645"/>
-              <a:gd name="csY1" fmla="*/ 12981 h 713832"/>
-              <a:gd name="csX0" fmla="*/ 0 w 130645"/>
-              <a:gd name="csY0" fmla="*/ 700839 h 700856"/>
-              <a:gd name="csX1" fmla="*/ 130645 w 130645"/>
-              <a:gd name="csY1" fmla="*/ 0 h 700856"/>
-            </a:gdLst>
-            <a:ahLst/>
-            <a:cxnLst>
-              <a:cxn ang="0">
-                <a:pos x="csX0" y="csY0"/>
-              </a:cxn>
-              <a:cxn ang="0">
-                <a:pos x="csX1" y="csY1"/>
-              </a:cxn>
-            </a:cxnLst>
-            <a:rect l="l" t="t" r="r" b="b"/>
-            <a:pathLst>
-              <a:path w="130645" h="700856">
-                <a:moveTo>
-                  <a:pt x="0" y="700839"/>
-                </a:moveTo>
-                <a:cubicBezTo>
-                  <a:pt x="148856" y="704383"/>
-                  <a:pt x="51268" y="170612"/>
-                  <a:pt x="130645" y="0"/>
-                </a:cubicBezTo>
-              </a:path>
-            </a:pathLst>
-          </a:custGeom>
-          <a:noFill/>
-          <a:ln w="28575">
-            <a:solidFill>
-              <a:srgbClr val="C00000"/>
-            </a:solidFill>
-            <a:prstDash val="solid"/>
-          </a:ln>
-        </p:spPr>
-        <p:style>
-          <a:lnRef idx="2">
-            <a:schemeClr val="accent1">
-              <a:shade val="15000"/>
-            </a:schemeClr>
-          </a:lnRef>
-          <a:fillRef idx="1">
-            <a:schemeClr val="accent1"/>
-          </a:fillRef>
-          <a:effectRef idx="0">
-            <a:schemeClr val="accent1"/>
-          </a:effectRef>
-          <a:fontRef idx="minor">
-            <a:schemeClr val="lt1"/>
-          </a:fontRef>
-        </p:style>
-        <p:txBody>
-          <a:bodyPr rtlCol="0" anchor="ctr"/>
-          <a:lstStyle/>
-          <a:p>
-            <a:pPr algn="ctr"/>
-            <a:endParaRPr lang="en-US"/>
-          </a:p>
-        </p:txBody>
-      </p:sp>
+      </p:cxnSp>
     </p:spTree>
     <p:extLst>
       <p:ext uri="{BB962C8B-B14F-4D97-AF65-F5344CB8AC3E}">

</xml_diff>